<commit_message>
Added clock source flag in USRP command line arguments.
</commit_message>
<xml_diff>
--- a/doc/episys/test_script/overview_sl_test.pptx
+++ b/doc/episys/test_script/overview_sl_test.pptx
@@ -8408,7 +8408,7 @@
         <p:spPr>
           <a:xfrm>
             <a:off x="6400800" y="1463040"/>
-            <a:ext cx="5029200" cy="2194560"/>
+            <a:ext cx="5029200" cy="2560320"/>
           </a:xfrm>
           <a:prstGeom prst="roundRect">
             <a:avLst/>
@@ -8483,6 +8483,70 @@
                 <a:latin typeface="Consolas"/>
               </a:rPr>
               <a:t/>
+            </a:r>
+          </a:p>
+          <a:p>
+            <a:pPr algn="l">
+              <a:spcAft>
+                <a:spcPts val="200"/>
+              </a:spcAft>
+            </a:pPr>
+            <a:r>
+              <a:rPr sz="1100">
+                <a:solidFill>
+                  <a:srgbClr val="E2E8F0"/>
+                </a:solidFill>
+                <a:latin typeface="Consolas"/>
+              </a:rPr>
+              <a:t># Use external clock for USRP (0/1)</a:t>
+            </a:r>
+          </a:p>
+          <a:p>
+            <a:pPr algn="l">
+              <a:spcAft>
+                <a:spcPts val="200"/>
+              </a:spcAft>
+            </a:pPr>
+            <a:r>
+              <a:rPr sz="1100">
+                <a:solidFill>
+                  <a:srgbClr val="E2E8F0"/>
+                </a:solidFill>
+                <a:latin typeface="Consolas"/>
+              </a:rPr>
+              <a:t>use_external_clock=1</a:t>
+            </a:r>
+          </a:p>
+          <a:p>
+            <a:pPr algn="l">
+              <a:spcAft>
+                <a:spcPts val="200"/>
+              </a:spcAft>
+            </a:pPr>
+            <a:r>
+              <a:rPr sz="1100">
+                <a:solidFill>
+                  <a:srgbClr val="E2E8F0"/>
+                </a:solidFill>
+                <a:latin typeface="Consolas"/>
+              </a:rPr>
+              <a:t># Use standalone mode (0/1)</a:t>
+            </a:r>
+          </a:p>
+          <a:p>
+            <a:pPr algn="l">
+              <a:spcAft>
+                <a:spcPts val="200"/>
+              </a:spcAft>
+            </a:pPr>
+            <a:r>
+              <a:rPr sz="1100">
+                <a:solidFill>
+                  <a:srgbClr val="E2E8F0"/>
+                </a:solidFill>
+                <a:latin typeface="Consolas"/>
+              </a:rPr>
+              <a:t>use_sa=1</a:t>
             </a:r>
           </a:p>
           <a:p>

</xml_diff>

<commit_message>
Added checking PC5 sync before ping test.
</commit_message>
<xml_diff>
--- a/doc/episys/test_script/overview_sl_test.pptx
+++ b/doc/episys/test_script/overview_sl_test.pptx
@@ -5159,7 +5159,7 @@
                 </a:solidFill>
                 <a:latin typeface="Consolas"/>
               </a:rPr>
-              <a:t>   d. Execute ping test</a:t>
+              <a:t>   d. Wait for PC5 sync (PSBCH decode)</a:t>
             </a:r>
           </a:p>
           <a:p>
@@ -5175,7 +5175,7 @@
                 </a:solidFill>
                 <a:latin typeface="Consolas"/>
               </a:rPr>
-              <a:t>   e. Collect stats (ping + PSSCH)</a:t>
+              <a:t>   e. Execute ping test</a:t>
             </a:r>
           </a:p>
           <a:p>
@@ -5191,7 +5191,7 @@
                 </a:solidFill>
                 <a:latin typeface="Consolas"/>
               </a:rPr>
-              <a:t>   f. Kill processes &amp; cleanup</a:t>
+              <a:t>   f. Collect stats (ping + PSSCH)</a:t>
             </a:r>
           </a:p>
           <a:p>
@@ -5207,7 +5207,7 @@
                 </a:solidFill>
                 <a:latin typeface="Consolas"/>
               </a:rPr>
-              <a:t>   g. Generate summary row</a:t>
+              <a:t>   g. Kill processes &amp; cleanup</a:t>
             </a:r>
           </a:p>
           <a:p>
@@ -5223,7 +5223,87 @@
                 </a:solidFill>
                 <a:latin typeface="Consolas"/>
               </a:rPr>
+              <a:t>   h. Generate summary row</a:t>
+            </a:r>
+          </a:p>
+          <a:p>
+            <a:pPr algn="l">
+              <a:spcAft>
+                <a:spcPts val="200"/>
+              </a:spcAft>
+            </a:pPr>
+            <a:r>
+              <a:rPr sz="1200">
+                <a:solidFill>
+                  <a:srgbClr val="E2E8F0"/>
+                </a:solidFill>
+                <a:latin typeface="Consolas"/>
+              </a:rPr>
               <a:t>4. Display final summary table</a:t>
+            </a:r>
+          </a:p>
+          <a:p>
+            <a:pPr algn="l">
+              <a:spcAft>
+                <a:spcPts val="200"/>
+              </a:spcAft>
+            </a:pPr>
+            <a:r>
+              <a:rPr sz="1200">
+                <a:solidFill>
+                  <a:srgbClr val="E2E8F0"/>
+                </a:solidFill>
+                <a:latin typeface="Consolas"/>
+              </a:rPr>
+              <a:t/>
+            </a:r>
+          </a:p>
+          <a:p>
+            <a:pPr algn="l">
+              <a:spcAft>
+                <a:spcPts val="200"/>
+              </a:spcAft>
+            </a:pPr>
+            <a:r>
+              <a:rPr sz="1200">
+                <a:solidFill>
+                  <a:srgbClr val="E2E8F0"/>
+                </a:solidFill>
+                <a:latin typeface="Consolas"/>
+              </a:rPr>
+              <a:t>Duration budget (ensure_ping_test_time):</a:t>
+            </a:r>
+          </a:p>
+          <a:p>
+            <a:pPr algn="l">
+              <a:spcAft>
+                <a:spcPts val="200"/>
+              </a:spcAft>
+            </a:pPr>
+            <a:r>
+              <a:rPr sz="1200">
+                <a:solidFill>
+                  <a:srgbClr val="E2E8F0"/>
+                </a:solidFill>
+                <a:latin typeface="Consolas"/>
+              </a:rPr>
+              <a:t>  =1: flexible, ping always runs (min 16s)</a:t>
+            </a:r>
+          </a:p>
+          <a:p>
+            <a:pPr algn="l">
+              <a:spcAft>
+                <a:spcPts val="200"/>
+              </a:spcAft>
+            </a:pPr>
+            <a:r>
+              <a:rPr sz="1200">
+                <a:solidFill>
+                  <a:srgbClr val="E2E8F0"/>
+                </a:solidFill>
+                <a:latin typeface="Consolas"/>
+              </a:rPr>
+              <a:t>  =0: strict, test ends after duration</a:t>
             </a:r>
           </a:p>
         </p:txBody>
@@ -8579,6 +8659,38 @@
                 <a:latin typeface="Consolas"/>
               </a:rPr>
               <a:t>use_gnome=1</a:t>
+            </a:r>
+          </a:p>
+          <a:p>
+            <a:pPr algn="l">
+              <a:spcAft>
+                <a:spcPts val="200"/>
+              </a:spcAft>
+            </a:pPr>
+            <a:r>
+              <a:rPr sz="1100">
+                <a:solidFill>
+                  <a:srgbClr val="E2E8F0"/>
+                </a:solidFill>
+                <a:latin typeface="Consolas"/>
+              </a:rPr>
+              <a:t># Ensure ping test time (0=strict, 1=flexible)</a:t>
+            </a:r>
+          </a:p>
+          <a:p>
+            <a:pPr algn="l">
+              <a:spcAft>
+                <a:spcPts val="200"/>
+              </a:spcAft>
+            </a:pPr>
+            <a:r>
+              <a:rPr sz="1100">
+                <a:solidFill>
+                  <a:srgbClr val="E2E8F0"/>
+                </a:solidFill>
+                <a:latin typeface="Consolas"/>
+              </a:rPr>
+              <a:t>ensure_ping_test_time=1</a:t>
             </a:r>
           </a:p>
           <a:p>

</xml_diff>

<commit_message>
Added iperf3 tests and updated README file.
</commit_message>
<xml_diff>
--- a/doc/episys/test_script/overview_sl_test.pptx
+++ b/doc/episys/test_script/overview_sl_test.pptx
@@ -4553,7 +4553,7 @@
                   <a:srgbClr val="1E293B"/>
                 </a:solidFill>
               </a:rPr>
-              <a:t>PC5 Mode 2 </a:t>
+              <a:t>Sidelink Mode 2 </a:t>
             </a:r>
             <a:r>
               <a:rPr sz="1400">
@@ -4576,7 +4576,7 @@
                   <a:srgbClr val="1E293B"/>
                 </a:solidFill>
               </a:rPr>
-              <a:t>PC5 Mode 1 </a:t>
+              <a:t>Sidelink Mode 1 </a:t>
             </a:r>
             <a:r>
               <a:rPr sz="1400">
@@ -4654,6 +4654,52 @@
                 </a:solidFill>
               </a:rPr>
               <a:t>— gNB &lt;-&gt; UE connectivity testing</a:t>
+            </a:r>
+          </a:p>
+          <a:p>
+            <a:pPr>
+              <a:spcAft>
+                <a:spcPts val="600"/>
+              </a:spcAft>
+            </a:pPr>
+            <a:r>
+              <a:rPr sz="1400" b="1">
+                <a:solidFill>
+                  <a:srgbClr val="1E293B"/>
+                </a:solidFill>
+              </a:rPr>
+              <a:t>iperf3 Bandwidth Sweep </a:t>
+            </a:r>
+            <a:r>
+              <a:rPr sz="1400">
+                <a:solidFill>
+                  <a:srgbClr val="1E293B"/>
+                </a:solidFill>
+              </a:rPr>
+              <a:t>— UDP throughput characterization</a:t>
+            </a:r>
+          </a:p>
+          <a:p>
+            <a:pPr>
+              <a:spcAft>
+                <a:spcPts val="600"/>
+              </a:spcAft>
+            </a:pPr>
+            <a:r>
+              <a:rPr sz="1400" b="1">
+                <a:solidFill>
+                  <a:srgbClr val="1E293B"/>
+                </a:solidFill>
+              </a:rPr>
+              <a:t>BLER Testing </a:t>
+            </a:r>
+            <a:r>
+              <a:rPr sz="1400">
+                <a:solidFill>
+                  <a:srgbClr val="1E293B"/>
+                </a:solidFill>
+              </a:rPr>
+              <a:t>— Waterfall curves across MCS 0-28 with noise sweep</a:t>
             </a:r>
           </a:p>
         </p:txBody>
@@ -4802,7 +4848,7 @@
                   <a:srgbClr val="1E293B"/>
                 </a:solidFill>
               </a:rPr>
-              <a:t>— pilot / regress / stress</a:t>
+              <a:t>— pilot / regress / stress / bler</a:t>
             </a:r>
           </a:p>
           <a:p>
@@ -5537,6 +5583,22 @@
                 </a:solidFill>
                 <a:latin typeface="Consolas"/>
               </a:rPr>
+              <a:t>    iperf3_summary_*.csv / *.png</a:t>
+            </a:r>
+          </a:p>
+          <a:p>
+            <a:pPr algn="l">
+              <a:spcAft>
+                <a:spcPts val="200"/>
+              </a:spcAft>
+            </a:pPr>
+            <a:r>
+              <a:rPr sz="1200">
+                <a:solidFill>
+                  <a:srgbClr val="E2E8F0"/>
+                </a:solidFill>
+                <a:latin typeface="Consolas"/>
+              </a:rPr>
               <a:t>    result_*_&lt;test&gt;_&lt;ts&gt;.log</a:t>
             </a:r>
           </a:p>
@@ -7579,7 +7641,7 @@
         </p:nvGraphicFramePr>
         <p:xfrm>
           <a:off x="548640" y="1463040"/>
-          <a:ext cx="5074920" cy="1463040"/>
+          <a:ext cx="5074920" cy="1828800"/>
         </p:xfrm>
         <a:graphic>
           <a:graphicData uri="http://schemas.openxmlformats.org/drawingml/2006/table">
@@ -8309,6 +8371,184 @@
                   </a:tcPr>
                 </a:tc>
               </a:tr>
+              <a:tr h="365760">
+                <a:tc>
+                  <a:txBody>
+                    <a:bodyPr/>
+                    <a:lstStyle/>
+                    <a:p>
+                      <a:pPr algn="l"/>
+                      <a:r>
+                        <a:rPr sz="1000" b="0">
+                          <a:solidFill>
+                            <a:srgbClr val="1E293B"/>
+                          </a:solidFill>
+                        </a:rPr>
+                        <a:t>bler</a:t>
+                      </a:r>
+                    </a:p>
+                  </a:txBody>
+                  <a:tcPr anchor="ctr">
+                    <a:solidFill>
+                      <a:srgbClr val="F4F8FC"/>
+                    </a:solidFill>
+                  </a:tcPr>
+                </a:tc>
+                <a:tc>
+                  <a:txBody>
+                    <a:bodyPr/>
+                    <a:lstStyle/>
+                    <a:p>
+                      <a:pPr algn="ctr"/>
+                      <a:r>
+                        <a:rPr sz="1000" b="0">
+                          <a:solidFill>
+                            <a:srgbClr val="1E293B"/>
+                          </a:solidFill>
+                        </a:rPr>
+                        <a:t>12</a:t>
+                      </a:r>
+                    </a:p>
+                  </a:txBody>
+                  <a:tcPr anchor="ctr">
+                    <a:solidFill>
+                      <a:srgbClr val="F4F8FC"/>
+                    </a:solidFill>
+                  </a:tcPr>
+                </a:tc>
+                <a:tc>
+                  <a:txBody>
+                    <a:bodyPr/>
+                    <a:lstStyle/>
+                    <a:p>
+                      <a:pPr algn="ctr"/>
+                      <a:r>
+                        <a:rPr sz="1000" b="0">
+                          <a:solidFill>
+                            <a:srgbClr val="1E293B"/>
+                          </a:solidFill>
+                        </a:rPr>
+                        <a:t>0-28</a:t>
+                      </a:r>
+                    </a:p>
+                  </a:txBody>
+                  <a:tcPr anchor="ctr">
+                    <a:solidFill>
+                      <a:srgbClr val="F4F8FC"/>
+                    </a:solidFill>
+                  </a:tcPr>
+                </a:tc>
+                <a:tc>
+                  <a:txBody>
+                    <a:bodyPr/>
+                    <a:lstStyle/>
+                    <a:p>
+                      <a:pPr algn="ctr"/>
+                      <a:r>
+                        <a:rPr sz="1000" b="0">
+                          <a:solidFill>
+                            <a:srgbClr val="1E293B"/>
+                          </a:solidFill>
+                        </a:rPr>
+                        <a:t>85s</a:t>
+                      </a:r>
+                    </a:p>
+                  </a:txBody>
+                  <a:tcPr anchor="ctr">
+                    <a:solidFill>
+                      <a:srgbClr val="F4F8FC"/>
+                    </a:solidFill>
+                  </a:tcPr>
+                </a:tc>
+                <a:tc>
+                  <a:txBody>
+                    <a:bodyPr/>
+                    <a:lstStyle/>
+                    <a:p>
+                      <a:pPr algn="ctr"/>
+                      <a:r>
+                        <a:rPr sz="1000" b="0">
+                          <a:solidFill>
+                            <a:srgbClr val="1E293B"/>
+                          </a:solidFill>
+                        </a:rPr>
+                        <a:t>Noise sweep</a:t>
+                      </a:r>
+                    </a:p>
+                  </a:txBody>
+                  <a:tcPr anchor="ctr">
+                    <a:solidFill>
+                      <a:srgbClr val="F4F8FC"/>
+                    </a:solidFill>
+                  </a:tcPr>
+                </a:tc>
+                <a:tc>
+                  <a:txBody>
+                    <a:bodyPr/>
+                    <a:lstStyle/>
+                    <a:p>
+                      <a:pPr algn="ctr"/>
+                      <a:r>
+                        <a:rPr sz="1000" b="0">
+                          <a:solidFill>
+                            <a:srgbClr val="1E293B"/>
+                          </a:solidFill>
+                        </a:rPr>
+                        <a:t>N/A</a:t>
+                      </a:r>
+                    </a:p>
+                  </a:txBody>
+                  <a:tcPr anchor="ctr">
+                    <a:solidFill>
+                      <a:srgbClr val="F4F8FC"/>
+                    </a:solidFill>
+                  </a:tcPr>
+                </a:tc>
+                <a:tc>
+                  <a:txBody>
+                    <a:bodyPr/>
+                    <a:lstStyle/>
+                    <a:p>
+                      <a:pPr algn="ctr"/>
+                      <a:r>
+                        <a:rPr sz="1000" b="0">
+                          <a:solidFill>
+                            <a:srgbClr val="1E293B"/>
+                          </a:solidFill>
+                        </a:rPr>
+                        <a:t>30</a:t>
+                      </a:r>
+                    </a:p>
+                  </a:txBody>
+                  <a:tcPr anchor="ctr">
+                    <a:solidFill>
+                      <a:srgbClr val="F4F8FC"/>
+                    </a:solidFill>
+                  </a:tcPr>
+                </a:tc>
+                <a:tc>
+                  <a:txBody>
+                    <a:bodyPr/>
+                    <a:lstStyle/>
+                    <a:p>
+                      <a:pPr algn="l"/>
+                      <a:r>
+                        <a:rPr sz="1000" b="0">
+                          <a:solidFill>
+                            <a:srgbClr val="1E293B"/>
+                          </a:solidFill>
+                        </a:rPr>
+                        <a:t>BLER waterfall curves</a:t>
+                      </a:r>
+                    </a:p>
+                  </a:txBody>
+                  <a:tcPr anchor="ctr">
+                    <a:solidFill>
+                      <a:srgbClr val="F4F8FC"/>
+                    </a:solidFill>
+                  </a:tcPr>
+                </a:tc>
+              </a:tr>
             </a:tbl>
           </a:graphicData>
         </a:graphic>
@@ -8321,7 +8561,7 @@
         </p:nvSpPr>
         <p:spPr>
           <a:xfrm>
-            <a:off x="548640" y="3200400"/>
+            <a:off x="548640" y="3474720"/>
             <a:ext cx="4572000" cy="457200"/>
           </a:xfrm>
           <a:prstGeom prst="rect">
@@ -8355,7 +8595,7 @@
         </p:nvSpPr>
         <p:spPr>
           <a:xfrm>
-            <a:off x="548640" y="3657600"/>
+            <a:off x="548640" y="3931920"/>
             <a:ext cx="5029200" cy="2286000"/>
           </a:xfrm>
           <a:prstGeom prst="rect">
@@ -8578,7 +8818,7 @@
                 </a:solidFill>
                 <a:latin typeface="Consolas"/>
               </a:rPr>
-              <a:t># Use external clock for USRP (0/1)</a:t>
+              <a:t># Use external clock source for USRP (0=internal, 1=external) </a:t>
             </a:r>
           </a:p>
           <a:p>
@@ -8610,7 +8850,7 @@
                 </a:solidFill>
                 <a:latin typeface="Consolas"/>
               </a:rPr>
-              <a:t># Use standalone mode (0/1)</a:t>
+              <a:t># Use standalone mode (0=disabled, 1=enabled)</a:t>
             </a:r>
           </a:p>
           <a:p>
@@ -8754,7 +8994,7 @@
                 </a:solidFill>
                 <a:latin typeface="Consolas"/>
               </a:rPr>
-              <a:t>RELAY_UE_USRP_SN_FOR_SL=3271246</a:t>
+              <a:t>RELAY_UE_USRP_SN_FOR_SL=340EA3B</a:t>
             </a:r>
           </a:p>
         </p:txBody>
@@ -9087,7 +9327,7 @@
         </p:nvGraphicFramePr>
         <p:xfrm>
           <a:off x="548640" y="1188720"/>
-          <a:ext cx="5943600" cy="4754880"/>
+          <a:ext cx="5943600" cy="6949440"/>
         </p:xfrm>
         <a:graphic>
           <a:graphicData uri="http://schemas.openxmlformats.org/drawingml/2006/table">
@@ -9793,7 +10033,7 @@
                             <a:srgbClr val="1E293B"/>
                           </a:solidFill>
                         </a:rPr>
-                        <a:t>slmode1_basic_tests</a:t>
+                        <a:t>slmode2_iperf3_tests</a:t>
                       </a:r>
                     </a:p>
                   </a:txBody>
@@ -9837,7 +10077,7 @@
                             <a:srgbClr val="1E293B"/>
                           </a:solidFill>
                         </a:rPr>
-                        <a:t>rfsim_slmode1_srap_ping_test_on_local_host</a:t>
+                        <a:t>rfsim_pc5_iperf3_test_on_local_host</a:t>
                       </a:r>
                     </a:p>
                   </a:txBody>
@@ -9905,7 +10145,7 @@
                             <a:srgbClr val="1E293B"/>
                           </a:solidFill>
                         </a:rPr>
-                        <a:t>rfsim_slmode1_srap_ping_test_on_three_hosts</a:t>
+                        <a:t>rfsim_pc5_iperf3_test_on_two_hosts</a:t>
                       </a:r>
                     </a:p>
                   </a:txBody>
@@ -9973,7 +10213,415 @@
                             <a:srgbClr val="1E293B"/>
                           </a:solidFill>
                         </a:rPr>
+                        <a:t>usrp_B210_pc5_iperf3_test_on_two_hosts</a:t>
+                      </a:r>
+                    </a:p>
+                  </a:txBody>
+                  <a:tcPr anchor="ctr">
+                    <a:solidFill>
+                      <a:srgbClr val="F4F8FC"/>
+                    </a:solidFill>
+                  </a:tcPr>
+                </a:tc>
+              </a:tr>
+              <a:tr h="365760">
+                <a:tc>
+                  <a:txBody>
+                    <a:bodyPr/>
+                    <a:lstStyle/>
+                    <a:p>
+                      <a:pPr algn="l"/>
+                      <a:r>
+                        <a:rPr sz="1000" b="0">
+                          <a:solidFill>
+                            <a:srgbClr val="1E293B"/>
+                          </a:solidFill>
+                        </a:rPr>
+                        <a:t>slmode1_basic_tests</a:t>
+                      </a:r>
+                    </a:p>
+                  </a:txBody>
+                  <a:tcPr anchor="ctr">
+                    <a:solidFill>
+                      <a:srgbClr val="FFFFFF"/>
+                    </a:solidFill>
+                  </a:tcPr>
+                </a:tc>
+                <a:tc>
+                  <a:txBody>
+                    <a:bodyPr/>
+                    <a:lstStyle/>
+                    <a:p>
+                      <a:pPr algn="ctr"/>
+                      <a:r>
+                        <a:rPr sz="1000" b="0">
+                          <a:solidFill>
+                            <a:srgbClr val="1E293B"/>
+                          </a:solidFill>
+                        </a:rPr>
+                        <a:t>0</a:t>
+                      </a:r>
+                    </a:p>
+                  </a:txBody>
+                  <a:tcPr anchor="ctr">
+                    <a:solidFill>
+                      <a:srgbClr val="FFFFFF"/>
+                    </a:solidFill>
+                  </a:tcPr>
+                </a:tc>
+                <a:tc>
+                  <a:txBody>
+                    <a:bodyPr/>
+                    <a:lstStyle/>
+                    <a:p>
+                      <a:pPr algn="l"/>
+                      <a:r>
+                        <a:rPr sz="1000" b="0">
+                          <a:solidFill>
+                            <a:srgbClr val="1E293B"/>
+                          </a:solidFill>
+                        </a:rPr>
+                        <a:t>rfsim_slmode1_srap_ping_test_on_local_host</a:t>
+                      </a:r>
+                    </a:p>
+                  </a:txBody>
+                  <a:tcPr anchor="ctr">
+                    <a:solidFill>
+                      <a:srgbClr val="FFFFFF"/>
+                    </a:solidFill>
+                  </a:tcPr>
+                </a:tc>
+              </a:tr>
+              <a:tr h="365760">
+                <a:tc>
+                  <a:txBody>
+                    <a:bodyPr/>
+                    <a:lstStyle/>
+                    <a:p>
+                      <a:pPr algn="l"/>
+                      <a:r>
+                        <a:rPr sz="1000" b="0">
+                          <a:solidFill>
+                            <a:srgbClr val="1E293B"/>
+                          </a:solidFill>
+                        </a:rPr>
+                        <a:t/>
+                      </a:r>
+                    </a:p>
+                  </a:txBody>
+                  <a:tcPr anchor="ctr">
+                    <a:solidFill>
+                      <a:srgbClr val="F4F8FC"/>
+                    </a:solidFill>
+                  </a:tcPr>
+                </a:tc>
+                <a:tc>
+                  <a:txBody>
+                    <a:bodyPr/>
+                    <a:lstStyle/>
+                    <a:p>
+                      <a:pPr algn="ctr"/>
+                      <a:r>
+                        <a:rPr sz="1000" b="0">
+                          <a:solidFill>
+                            <a:srgbClr val="1E293B"/>
+                          </a:solidFill>
+                        </a:rPr>
+                        <a:t>1</a:t>
+                      </a:r>
+                    </a:p>
+                  </a:txBody>
+                  <a:tcPr anchor="ctr">
+                    <a:solidFill>
+                      <a:srgbClr val="F4F8FC"/>
+                    </a:solidFill>
+                  </a:tcPr>
+                </a:tc>
+                <a:tc>
+                  <a:txBody>
+                    <a:bodyPr/>
+                    <a:lstStyle/>
+                    <a:p>
+                      <a:pPr algn="l"/>
+                      <a:r>
+                        <a:rPr sz="1000" b="0">
+                          <a:solidFill>
+                            <a:srgbClr val="1E293B"/>
+                          </a:solidFill>
+                        </a:rPr>
+                        <a:t>rfsim_slmode1_srap_ping_test_on_three_hosts</a:t>
+                      </a:r>
+                    </a:p>
+                  </a:txBody>
+                  <a:tcPr anchor="ctr">
+                    <a:solidFill>
+                      <a:srgbClr val="F4F8FC"/>
+                    </a:solidFill>
+                  </a:tcPr>
+                </a:tc>
+              </a:tr>
+              <a:tr h="365760">
+                <a:tc>
+                  <a:txBody>
+                    <a:bodyPr/>
+                    <a:lstStyle/>
+                    <a:p>
+                      <a:pPr algn="l"/>
+                      <a:r>
+                        <a:rPr sz="1000" b="0">
+                          <a:solidFill>
+                            <a:srgbClr val="1E293B"/>
+                          </a:solidFill>
+                        </a:rPr>
+                        <a:t/>
+                      </a:r>
+                    </a:p>
+                  </a:txBody>
+                  <a:tcPr anchor="ctr">
+                    <a:solidFill>
+                      <a:srgbClr val="FFFFFF"/>
+                    </a:solidFill>
+                  </a:tcPr>
+                </a:tc>
+                <a:tc>
+                  <a:txBody>
+                    <a:bodyPr/>
+                    <a:lstStyle/>
+                    <a:p>
+                      <a:pPr algn="ctr"/>
+                      <a:r>
+                        <a:rPr sz="1000" b="0">
+                          <a:solidFill>
+                            <a:srgbClr val="1E293B"/>
+                          </a:solidFill>
+                        </a:rPr>
+                        <a:t>2</a:t>
+                      </a:r>
+                    </a:p>
+                  </a:txBody>
+                  <a:tcPr anchor="ctr">
+                    <a:solidFill>
+                      <a:srgbClr val="FFFFFF"/>
+                    </a:solidFill>
+                  </a:tcPr>
+                </a:tc>
+                <a:tc>
+                  <a:txBody>
+                    <a:bodyPr/>
+                    <a:lstStyle/>
+                    <a:p>
+                      <a:pPr algn="l"/>
+                      <a:r>
+                        <a:rPr sz="1000" b="0">
+                          <a:solidFill>
+                            <a:srgbClr val="1E293B"/>
+                          </a:solidFill>
+                        </a:rPr>
                         <a:t>usrp_B210_slmode1_srap_ping_test_on_three_hosts</a:t>
+                      </a:r>
+                    </a:p>
+                  </a:txBody>
+                  <a:tcPr anchor="ctr">
+                    <a:solidFill>
+                      <a:srgbClr val="FFFFFF"/>
+                    </a:solidFill>
+                  </a:tcPr>
+                </a:tc>
+              </a:tr>
+              <a:tr h="365760">
+                <a:tc>
+                  <a:txBody>
+                    <a:bodyPr/>
+                    <a:lstStyle/>
+                    <a:p>
+                      <a:pPr algn="l"/>
+                      <a:r>
+                        <a:rPr sz="1000" b="0">
+                          <a:solidFill>
+                            <a:srgbClr val="1E293B"/>
+                          </a:solidFill>
+                        </a:rPr>
+                        <a:t>slmode1_iperf3_tests</a:t>
+                      </a:r>
+                    </a:p>
+                  </a:txBody>
+                  <a:tcPr anchor="ctr">
+                    <a:solidFill>
+                      <a:srgbClr val="F4F8FC"/>
+                    </a:solidFill>
+                  </a:tcPr>
+                </a:tc>
+                <a:tc>
+                  <a:txBody>
+                    <a:bodyPr/>
+                    <a:lstStyle/>
+                    <a:p>
+                      <a:pPr algn="ctr"/>
+                      <a:r>
+                        <a:rPr sz="1000" b="0">
+                          <a:solidFill>
+                            <a:srgbClr val="1E293B"/>
+                          </a:solidFill>
+                        </a:rPr>
+                        <a:t>0</a:t>
+                      </a:r>
+                    </a:p>
+                  </a:txBody>
+                  <a:tcPr anchor="ctr">
+                    <a:solidFill>
+                      <a:srgbClr val="F4F8FC"/>
+                    </a:solidFill>
+                  </a:tcPr>
+                </a:tc>
+                <a:tc>
+                  <a:txBody>
+                    <a:bodyPr/>
+                    <a:lstStyle/>
+                    <a:p>
+                      <a:pPr algn="l"/>
+                      <a:r>
+                        <a:rPr sz="1000" b="0">
+                          <a:solidFill>
+                            <a:srgbClr val="1E293B"/>
+                          </a:solidFill>
+                        </a:rPr>
+                        <a:t>rfsim_slmode1_srap_iperf3_test_on_local_host</a:t>
+                      </a:r>
+                    </a:p>
+                  </a:txBody>
+                  <a:tcPr anchor="ctr">
+                    <a:solidFill>
+                      <a:srgbClr val="F4F8FC"/>
+                    </a:solidFill>
+                  </a:tcPr>
+                </a:tc>
+              </a:tr>
+              <a:tr h="365760">
+                <a:tc>
+                  <a:txBody>
+                    <a:bodyPr/>
+                    <a:lstStyle/>
+                    <a:p>
+                      <a:pPr algn="l"/>
+                      <a:r>
+                        <a:rPr sz="1000" b="0">
+                          <a:solidFill>
+                            <a:srgbClr val="1E293B"/>
+                          </a:solidFill>
+                        </a:rPr>
+                        <a:t/>
+                      </a:r>
+                    </a:p>
+                  </a:txBody>
+                  <a:tcPr anchor="ctr">
+                    <a:solidFill>
+                      <a:srgbClr val="FFFFFF"/>
+                    </a:solidFill>
+                  </a:tcPr>
+                </a:tc>
+                <a:tc>
+                  <a:txBody>
+                    <a:bodyPr/>
+                    <a:lstStyle/>
+                    <a:p>
+                      <a:pPr algn="ctr"/>
+                      <a:r>
+                        <a:rPr sz="1000" b="0">
+                          <a:solidFill>
+                            <a:srgbClr val="1E293B"/>
+                          </a:solidFill>
+                        </a:rPr>
+                        <a:t>1</a:t>
+                      </a:r>
+                    </a:p>
+                  </a:txBody>
+                  <a:tcPr anchor="ctr">
+                    <a:solidFill>
+                      <a:srgbClr val="FFFFFF"/>
+                    </a:solidFill>
+                  </a:tcPr>
+                </a:tc>
+                <a:tc>
+                  <a:txBody>
+                    <a:bodyPr/>
+                    <a:lstStyle/>
+                    <a:p>
+                      <a:pPr algn="l"/>
+                      <a:r>
+                        <a:rPr sz="1000" b="0">
+                          <a:solidFill>
+                            <a:srgbClr val="1E293B"/>
+                          </a:solidFill>
+                        </a:rPr>
+                        <a:t>rfsim_slmode1_srap_iperf3_test_on_three_hosts</a:t>
+                      </a:r>
+                    </a:p>
+                  </a:txBody>
+                  <a:tcPr anchor="ctr">
+                    <a:solidFill>
+                      <a:srgbClr val="FFFFFF"/>
+                    </a:solidFill>
+                  </a:tcPr>
+                </a:tc>
+              </a:tr>
+              <a:tr h="365760">
+                <a:tc>
+                  <a:txBody>
+                    <a:bodyPr/>
+                    <a:lstStyle/>
+                    <a:p>
+                      <a:pPr algn="l"/>
+                      <a:r>
+                        <a:rPr sz="1000" b="0">
+                          <a:solidFill>
+                            <a:srgbClr val="1E293B"/>
+                          </a:solidFill>
+                        </a:rPr>
+                        <a:t/>
+                      </a:r>
+                    </a:p>
+                  </a:txBody>
+                  <a:tcPr anchor="ctr">
+                    <a:solidFill>
+                      <a:srgbClr val="F4F8FC"/>
+                    </a:solidFill>
+                  </a:tcPr>
+                </a:tc>
+                <a:tc>
+                  <a:txBody>
+                    <a:bodyPr/>
+                    <a:lstStyle/>
+                    <a:p>
+                      <a:pPr algn="ctr"/>
+                      <a:r>
+                        <a:rPr sz="1000" b="0">
+                          <a:solidFill>
+                            <a:srgbClr val="1E293B"/>
+                          </a:solidFill>
+                        </a:rPr>
+                        <a:t>2</a:t>
+                      </a:r>
+                    </a:p>
+                  </a:txBody>
+                  <a:tcPr anchor="ctr">
+                    <a:solidFill>
+                      <a:srgbClr val="F4F8FC"/>
+                    </a:solidFill>
+                  </a:tcPr>
+                </a:tc>
+                <a:tc>
+                  <a:txBody>
+                    <a:bodyPr/>
+                    <a:lstStyle/>
+                    <a:p>
+                      <a:pPr algn="l"/>
+                      <a:r>
+                        <a:rPr sz="1000" b="0">
+                          <a:solidFill>
+                            <a:srgbClr val="1E293B"/>
+                          </a:solidFill>
+                        </a:rPr>
+                        <a:t>usrp_B210_slmode1_srap_iperf3_test_on_three_hosts</a:t>
                       </a:r>
                     </a:p>
                   </a:txBody>
@@ -10465,7 +11113,7 @@
         </p:nvGraphicFramePr>
         <p:xfrm>
           <a:off x="548640" y="1188720"/>
-          <a:ext cx="10972800" cy="3291840"/>
+          <a:ext cx="10972800" cy="3657600"/>
         </p:xfrm>
         <a:graphic>
           <a:graphicData uri="http://schemas.openxmlformats.org/drawingml/2006/table">
@@ -11032,7 +11680,7 @@
                             <a:srgbClr val="1E293B"/>
                           </a:solidFill>
                         </a:rPr>
-                        <a:t>rfsim_slmode1_srap_*_on_local_host</a:t>
+                        <a:t>rfsim_pc5_iperf3_test_on_*</a:t>
                       </a:r>
                     </a:p>
                   </a:txBody>
@@ -11054,7 +11702,7 @@
                             <a:srgbClr val="1E293B"/>
                           </a:solidFill>
                         </a:rPr>
-                        <a:t>SL Mode 1</a:t>
+                        <a:t>SL Mode 2</a:t>
                       </a:r>
                     </a:p>
                   </a:txBody>
@@ -11076,7 +11724,7 @@
                             <a:srgbClr val="1E293B"/>
                           </a:solidFill>
                         </a:rPr>
-                        <a:t>1</a:t>
+                        <a:t>1-2</a:t>
                       </a:r>
                     </a:p>
                   </a:txBody>
@@ -11098,7 +11746,7 @@
                             <a:srgbClr val="1E293B"/>
                           </a:solidFill>
                         </a:rPr>
-                        <a:t>U2N relay via SRAP on localhost (requires 5G Core)</a:t>
+                        <a:t>iperf3 bandwidth sweep over PC5</a:t>
                       </a:r>
                     </a:p>
                   </a:txBody>
@@ -11122,7 +11770,7 @@
                             <a:srgbClr val="1E293B"/>
                           </a:solidFill>
                         </a:rPr>
-                        <a:t>rfsim_slmode1_srap_*_on_three_hosts</a:t>
+                        <a:t>rfsim_slmode1_srap_ping_*</a:t>
                       </a:r>
                     </a:p>
                   </a:txBody>
@@ -11166,7 +11814,7 @@
                             <a:srgbClr val="1E293B"/>
                           </a:solidFill>
                         </a:rPr>
-                        <a:t>3</a:t>
+                        <a:t>1, 3</a:t>
                       </a:r>
                     </a:p>
                   </a:txBody>
@@ -11188,7 +11836,7 @@
                             <a:srgbClr val="1E293B"/>
                           </a:solidFill>
                         </a:rPr>
-                        <a:t>U2N relay: gNB + Relay + Remote</a:t>
+                        <a:t>U2N relay ping via SRAP</a:t>
                       </a:r>
                     </a:p>
                   </a:txBody>
@@ -11212,13 +11860,103 @@
                             <a:srgbClr val="1E293B"/>
                           </a:solidFill>
                         </a:rPr>
+                        <a:t>rfsim_slmode1_srap_iperf3_*</a:t>
+                      </a:r>
+                    </a:p>
+                  </a:txBody>
+                  <a:tcPr anchor="ctr">
+                    <a:solidFill>
+                      <a:srgbClr val="F4F8FC"/>
+                    </a:solidFill>
+                  </a:tcPr>
+                </a:tc>
+                <a:tc>
+                  <a:txBody>
+                    <a:bodyPr/>
+                    <a:lstStyle/>
+                    <a:p>
+                      <a:pPr algn="ctr"/>
+                      <a:r>
+                        <a:rPr sz="1000" b="0">
+                          <a:solidFill>
+                            <a:srgbClr val="1E293B"/>
+                          </a:solidFill>
+                        </a:rPr>
+                        <a:t>SL Mode 1</a:t>
+                      </a:r>
+                    </a:p>
+                  </a:txBody>
+                  <a:tcPr anchor="ctr">
+                    <a:solidFill>
+                      <a:srgbClr val="F4F8FC"/>
+                    </a:solidFill>
+                  </a:tcPr>
+                </a:tc>
+                <a:tc>
+                  <a:txBody>
+                    <a:bodyPr/>
+                    <a:lstStyle/>
+                    <a:p>
+                      <a:pPr algn="ctr"/>
+                      <a:r>
+                        <a:rPr sz="1000" b="0">
+                          <a:solidFill>
+                            <a:srgbClr val="1E293B"/>
+                          </a:solidFill>
+                        </a:rPr>
+                        <a:t>1, 3</a:t>
+                      </a:r>
+                    </a:p>
+                  </a:txBody>
+                  <a:tcPr anchor="ctr">
+                    <a:solidFill>
+                      <a:srgbClr val="F4F8FC"/>
+                    </a:solidFill>
+                  </a:tcPr>
+                </a:tc>
+                <a:tc>
+                  <a:txBody>
+                    <a:bodyPr/>
+                    <a:lstStyle/>
+                    <a:p>
+                      <a:pPr algn="l"/>
+                      <a:r>
+                        <a:rPr sz="1000" b="0">
+                          <a:solidFill>
+                            <a:srgbClr val="1E293B"/>
+                          </a:solidFill>
+                        </a:rPr>
+                        <a:t>U2N relay iperf3 bandwidth sweep</a:t>
+                      </a:r>
+                    </a:p>
+                  </a:txBody>
+                  <a:tcPr anchor="ctr">
+                    <a:solidFill>
+                      <a:srgbClr val="F4F8FC"/>
+                    </a:solidFill>
+                  </a:tcPr>
+                </a:tc>
+              </a:tr>
+              <a:tr h="365760">
+                <a:tc>
+                  <a:txBody>
+                    <a:bodyPr/>
+                    <a:lstStyle/>
+                    <a:p>
+                      <a:pPr algn="l"/>
+                      <a:r>
+                        <a:rPr sz="1000" b="0">
+                          <a:solidFill>
+                            <a:srgbClr val="1E293B"/>
+                          </a:solidFill>
+                        </a:rPr>
                         <a:t>usrp_B210_*</a:t>
                       </a:r>
                     </a:p>
                   </a:txBody>
                   <a:tcPr anchor="ctr">
                     <a:solidFill>
-                      <a:srgbClr val="F4F8FC"/>
+                      <a:srgbClr val="FFFFFF"/>
                     </a:solidFill>
                   </a:tcPr>
                 </a:tc>
@@ -11240,7 +11978,7 @@
                   </a:txBody>
                   <a:tcPr anchor="ctr">
                     <a:solidFill>
-                      <a:srgbClr val="F4F8FC"/>
+                      <a:srgbClr val="FFFFFF"/>
                     </a:solidFill>
                   </a:tcPr>
                 </a:tc>
@@ -11262,7 +12000,7 @@
                   </a:txBody>
                   <a:tcPr anchor="ctr">
                     <a:solidFill>
-                      <a:srgbClr val="F4F8FC"/>
+                      <a:srgbClr val="FFFFFF"/>
                     </a:solidFill>
                   </a:tcPr>
                 </a:tc>
@@ -11284,7 +12022,7 @@
                   </a:txBody>
                   <a:tcPr anchor="ctr">
                     <a:solidFill>
-                      <a:srgbClr val="F4F8FC"/>
+                      <a:srgbClr val="FFFFFF"/>
                     </a:solidFill>
                   </a:tcPr>
                 </a:tc>
@@ -11804,6 +12542,21 @@
                   <a:srgbClr val="1E293B"/>
                 </a:solidFill>
               </a:rPr>
+              <a:t>•  iperf3_summary_*.csv / *.png — iperf3 results &amp; plot</a:t>
+            </a:r>
+          </a:p>
+          <a:p>
+            <a:pPr>
+              <a:spcAft>
+                <a:spcPts val="400"/>
+              </a:spcAft>
+            </a:pPr>
+            <a:r>
+              <a:rPr sz="1200">
+                <a:solidFill>
+                  <a:srgbClr val="1E293B"/>
+                </a:solidFill>
+              </a:rPr>
               <a:t>•  result_&lt;component&gt;_&lt;test_name&gt;_&lt;ts&gt;.log — softmodem output</a:t>
             </a:r>
           </a:p>
@@ -11819,7 +12572,7 @@
                   <a:srgbClr val="1E293B"/>
                 </a:solidFill>
               </a:rPr>
-              <a:t>•    (gNB, nrUE, syncref, nearby, nrUE_syncref)</a:t>
+              <a:t>•  ping_result_*.txt — ping output</a:t>
             </a:r>
           </a:p>
           <a:p>
@@ -11834,7 +12587,7 @@
                   <a:srgbClr val="1E293B"/>
                 </a:solidFill>
               </a:rPr>
-              <a:t>•  ping_result_*.txt — ping output</a:t>
+              <a:t>•  iperf3_server_*.txt / iperf3_client_*.txt — iperf3 logs</a:t>
             </a:r>
           </a:p>
         </p:txBody>

</xml_diff>

<commit_message>
Fixed PSSCH stat to clamp RX to paired TX in sidelink test script.
</commit_message>
<xml_diff>
--- a/doc/episys/test_script/overview_sl_test.pptx
+++ b/doc/episys/test_script/overview_sl_test.pptx
@@ -14223,7 +14223,7 @@
                 </a:solidFill>
                 <a:latin typeface="Consolas"/>
               </a:rPr>
-              <a:t>rfsim_pc5_ping_test_on_local_host              |    1 |     1 |   1 |    35s  |  100% | 1234/1200 (97%) | 1150/1234 (93%) |   95% |   PASS</a:t>
+              <a:t>rfsim_pc5_ping_test_on_local_host              |    1 |     1 |   9 |     40s |  100% | 33/33 (100%)    | 33/33 (100%)    |  100% |   PASS</a:t>
             </a:r>
           </a:p>
           <a:p>
@@ -14239,7 +14239,7 @@
                 </a:solidFill>
                 <a:latin typeface="Consolas"/>
               </a:rPr>
-              <a:t>rfsim_pc5_csi_psfch_*_csi0_psfch1              |    1 |     2 |   1 |    38s  |   93% | 980/1000 (98%)  | 920/980 (93%)   |   96% |   PASS</a:t>
+              <a:t>rfsim_pc5_csi_psfch_*_csi0_psfch1              |    1 |     2 |   9 |     44s |  100% | 12/12 (100%)    | 8/8 (100%)      |  100% |   PASS</a:t>
             </a:r>
           </a:p>
           <a:p>
@@ -14255,7 +14255,7 @@
                 </a:solidFill>
                 <a:latin typeface="Consolas"/>
               </a:rPr>
-              <a:t>rfsim_slmode1_srap_ping_test_on_local_host     |    1 |     1 |   1 |    42s  |   80% | N/A             | N/A             |   N/A |   PASS</a:t>
+              <a:t>rfsim_slmode1_srap_ping_test_on_local_host     |    1 |     1 |   9 |     58s |  100% | 36/36 (100%)    | 38/38 (100%)    |  100% |   PASS</a:t>
             </a:r>
           </a:p>
         </p:txBody>
@@ -14469,7 +14469,7 @@
                   <a:srgbClr val="1E293B"/>
                 </a:solidFill>
               </a:rPr>
-              <a:t>•  iperf3_summary_*.csv / *.png — iperf3 results &amp; plot</a:t>
+              <a:t>•  iperf3_summary_*.csv / *.png — iperf3 bandwidth/loss plot</a:t>
             </a:r>
           </a:p>
           <a:p>

</xml_diff>

<commit_message>
Supporting vrtsim: vendor shared-memory radio framework
</commit_message>
<xml_diff>
--- a/doc/episys/test_script/overview_sl_test.pptx
+++ b/doc/episys/test_script/overview_sl_test.pptx
@@ -3251,8 +3251,8 @@
         </p:nvSpPr>
         <p:spPr>
           <a:xfrm>
-            <a:off x="2560320" y="4389120"/>
-            <a:ext cx="1645920" cy="365760"/>
+            <a:off x="2804007" y="4389120"/>
+            <a:ext cx="1371600" cy="365760"/>
           </a:xfrm>
           <a:prstGeom prst="roundRect">
             <a:avLst/>
@@ -3281,7 +3281,7 @@
           </a:fontRef>
         </p:style>
         <p:txBody>
-          <a:bodyPr rtlCol="0" anchor="ctr"/>
+          <a:bodyPr rtlCol="0" anchor="ctr" wrap="none"/>
           <a:lstStyle/>
           <a:p>
             <a:pPr algn="ctr"/>
@@ -3304,8 +3304,8 @@
         </p:nvSpPr>
         <p:spPr>
           <a:xfrm>
-            <a:off x="4389120" y="4389120"/>
-            <a:ext cx="1645920" cy="365760"/>
+            <a:off x="4358487" y="4389120"/>
+            <a:ext cx="1097280" cy="365760"/>
           </a:xfrm>
           <a:prstGeom prst="roundRect">
             <a:avLst/>
@@ -3334,7 +3334,7 @@
           </a:fontRef>
         </p:style>
         <p:txBody>
-          <a:bodyPr rtlCol="0" anchor="ctr"/>
+          <a:bodyPr rtlCol="0" anchor="ctr" wrap="none"/>
           <a:lstStyle/>
           <a:p>
             <a:pPr algn="ctr"/>
@@ -3357,8 +3357,8 @@
         </p:nvSpPr>
         <p:spPr>
           <a:xfrm>
-            <a:off x="6217920" y="4389120"/>
-            <a:ext cx="1645920" cy="365760"/>
+            <a:off x="5638647" y="4389120"/>
+            <a:ext cx="1554480" cy="365760"/>
           </a:xfrm>
           <a:prstGeom prst="roundRect">
             <a:avLst/>
@@ -3387,7 +3387,7 @@
           </a:fontRef>
         </p:style>
         <p:txBody>
-          <a:bodyPr rtlCol="0" anchor="ctr"/>
+          <a:bodyPr rtlCol="0" anchor="ctr" wrap="none"/>
           <a:lstStyle/>
           <a:p>
             <a:pPr algn="ctr"/>
@@ -3410,8 +3410,8 @@
         </p:nvSpPr>
         <p:spPr>
           <a:xfrm>
-            <a:off x="8046720" y="4389120"/>
-            <a:ext cx="1645920" cy="365760"/>
+            <a:off x="7376007" y="4389120"/>
+            <a:ext cx="2011680" cy="365760"/>
           </a:xfrm>
           <a:prstGeom prst="roundRect">
             <a:avLst/>
@@ -3440,7 +3440,7 @@
           </a:fontRef>
         </p:style>
         <p:txBody>
-          <a:bodyPr rtlCol="0" anchor="ctr"/>
+          <a:bodyPr rtlCol="0" anchor="ctr" wrap="none"/>
           <a:lstStyle/>
           <a:p>
             <a:pPr algn="ctr"/>
@@ -3450,7 +3450,7 @@
                   <a:srgbClr val="FFFFFF"/>
                 </a:solidFill>
               </a:rPr>
-              <a:t>RF Sim &amp; USRP</a:t>
+              <a:t>RF Sim, VRT Sim &amp; USRP</a:t>
             </a:r>
           </a:p>
         </p:txBody>
@@ -5890,6 +5890,29 @@
               <a:t>— ping + PSSCH statistics</a:t>
             </a:r>
           </a:p>
+          <a:p>
+            <a:pPr>
+              <a:spcAft>
+                <a:spcPts val="600"/>
+              </a:spcAft>
+            </a:pPr>
+            <a:r>
+              <a:rPr sz="1400" b="1">
+                <a:solidFill>
+                  <a:srgbClr val="1E293B"/>
+                </a:solidFill>
+              </a:rPr>
+              <a:t>Three radio backends </a:t>
+            </a:r>
+            <a:r>
+              <a:rPr sz="1400">
+                <a:solidFill>
+                  <a:srgbClr val="1E293B"/>
+                </a:solidFill>
+              </a:rPr>
+              <a:t>— rfsim (socket) / usrp (B210 HW) / vrtsim (shared-memory, local host)</a:t>
+            </a:r>
+          </a:p>
         </p:txBody>
       </p:sp>
       <p:sp>
@@ -7094,7 +7117,7 @@
         </p:nvGraphicFramePr>
         <p:xfrm>
           <a:off x="6400800" y="1554480"/>
-          <a:ext cx="5029200" cy="3657600"/>
+          <a:ext cx="5029200" cy="4754880"/>
         </p:xfrm>
         <a:graphic>
           <a:graphicData uri="http://schemas.openxmlformats.org/drawingml/2006/table">
@@ -7659,7 +7682,7 @@
                             <a:srgbClr val="1E293B"/>
                           </a:solidFill>
                         </a:rPr>
-                        <a:t>Mode 1 (SRAP)</a:t>
+                        <a:t>Mode 2</a:t>
                       </a:r>
                     </a:p>
                   </a:txBody>
@@ -7681,7 +7704,7 @@
                             <a:srgbClr val="1E293B"/>
                           </a:solidFill>
                         </a:rPr>
-                        <a:t>RFSIM</a:t>
+                        <a:t>VRTSIM</a:t>
                       </a:r>
                     </a:p>
                   </a:txBody>
@@ -7725,7 +7748,7 @@
                             <a:srgbClr val="1E293B"/>
                           </a:solidFill>
                         </a:rPr>
-                        <a:t>local</a:t>
+                        <a:t>—</a:t>
                       </a:r>
                     </a:p>
                   </a:txBody>
@@ -7837,7 +7860,7 @@
                             <a:srgbClr val="1E293B"/>
                           </a:solidFill>
                         </a:rPr>
-                        <a:t>3</a:t>
+                        <a:t>1</a:t>
                       </a:r>
                     </a:p>
                   </a:txBody>
@@ -7859,7 +7882,7 @@
                             <a:srgbClr val="1E293B"/>
                           </a:solidFill>
                         </a:rPr>
-                        <a:t>gNB, local</a:t>
+                        <a:t>local</a:t>
                       </a:r>
                     </a:p>
                   </a:txBody>
@@ -7881,7 +7904,7 @@
                             <a:srgbClr val="1E293B"/>
                           </a:solidFill>
                         </a:rPr>
-                        <a:t>relay_ue</a:t>
+                        <a:t>local</a:t>
                       </a:r>
                     </a:p>
                   </a:txBody>
@@ -7903,7 +7926,7 @@
                             <a:srgbClr val="1E293B"/>
                           </a:solidFill>
                         </a:rPr>
-                        <a:t>remote_ue</a:t>
+                        <a:t>local</a:t>
                       </a:r>
                     </a:p>
                   </a:txBody>
@@ -7949,7 +7972,7 @@
                             <a:srgbClr val="1E293B"/>
                           </a:solidFill>
                         </a:rPr>
-                        <a:t>USRP</a:t>
+                        <a:t>RFSIM</a:t>
                       </a:r>
                     </a:p>
                   </a:txBody>
@@ -7993,7 +8016,7 @@
                             <a:srgbClr val="1E293B"/>
                           </a:solidFill>
                         </a:rPr>
-                        <a:t>local</a:t>
+                        <a:t>gNB, local</a:t>
                       </a:r>
                     </a:p>
                   </a:txBody>
@@ -8061,7 +8084,7 @@
                             <a:srgbClr val="1E293B"/>
                           </a:solidFill>
                         </a:rPr>
-                        <a:t>Uu</a:t>
+                        <a:t>Mode 1 (SRAP)</a:t>
                       </a:r>
                     </a:p>
                   </a:txBody>
@@ -8083,7 +8106,7 @@
                             <a:srgbClr val="1E293B"/>
                           </a:solidFill>
                         </a:rPr>
-                        <a:t>RFSIM</a:t>
+                        <a:t>USRP</a:t>
                       </a:r>
                     </a:p>
                   </a:txBody>
@@ -8105,7 +8128,7 @@
                             <a:srgbClr val="1E293B"/>
                           </a:solidFill>
                         </a:rPr>
-                        <a:t>1</a:t>
+                        <a:t>3</a:t>
                       </a:r>
                     </a:p>
                   </a:txBody>
@@ -8149,7 +8172,7 @@
                             <a:srgbClr val="1E293B"/>
                           </a:solidFill>
                         </a:rPr>
-                        <a:t>—</a:t>
+                        <a:t>relay_ue</a:t>
                       </a:r>
                     </a:p>
                   </a:txBody>
@@ -8171,7 +8194,7 @@
                             <a:srgbClr val="1E293B"/>
                           </a:solidFill>
                         </a:rPr>
-                        <a:t>local (nrUE)</a:t>
+                        <a:t>remote_ue</a:t>
                       </a:r>
                     </a:p>
                   </a:txBody>
@@ -8195,7 +8218,7 @@
                             <a:srgbClr val="1E293B"/>
                           </a:solidFill>
                         </a:rPr>
-                        <a:t>Uu</a:t>
+                        <a:t>Mode 1 (SRAP)</a:t>
                       </a:r>
                     </a:p>
                   </a:txBody>
@@ -8217,7 +8240,7 @@
                             <a:srgbClr val="1E293B"/>
                           </a:solidFill>
                         </a:rPr>
-                        <a:t>RFSIM</a:t>
+                        <a:t>VRTSIM</a:t>
                       </a:r>
                     </a:p>
                   </a:txBody>
@@ -8239,7 +8262,7 @@
                             <a:srgbClr val="1E293B"/>
                           </a:solidFill>
                         </a:rPr>
-                        <a:t>2</a:t>
+                        <a:t>1</a:t>
                       </a:r>
                     </a:p>
                   </a:txBody>
@@ -8283,7 +8306,7 @@
                             <a:srgbClr val="1E293B"/>
                           </a:solidFill>
                         </a:rPr>
-                        <a:t>—</a:t>
+                        <a:t>local</a:t>
                       </a:r>
                     </a:p>
                   </a:txBody>
@@ -8305,7 +8328,7 @@
                             <a:srgbClr val="1E293B"/>
                           </a:solidFill>
                         </a:rPr>
-                        <a:t>nr_ue (nrUE)</a:t>
+                        <a:t>local</a:t>
                       </a:r>
                     </a:p>
                   </a:txBody>
@@ -8351,6 +8374,274 @@
                             <a:srgbClr val="1E293B"/>
                           </a:solidFill>
                         </a:rPr>
+                        <a:t>RFSIM</a:t>
+                      </a:r>
+                    </a:p>
+                  </a:txBody>
+                  <a:tcPr anchor="ctr">
+                    <a:solidFill>
+                      <a:srgbClr val="FFFFFF"/>
+                    </a:solidFill>
+                  </a:tcPr>
+                </a:tc>
+                <a:tc>
+                  <a:txBody>
+                    <a:bodyPr/>
+                    <a:lstStyle/>
+                    <a:p>
+                      <a:pPr algn="ctr"/>
+                      <a:r>
+                        <a:rPr sz="1000" b="0">
+                          <a:solidFill>
+                            <a:srgbClr val="1E293B"/>
+                          </a:solidFill>
+                        </a:rPr>
+                        <a:t>1</a:t>
+                      </a:r>
+                    </a:p>
+                  </a:txBody>
+                  <a:tcPr anchor="ctr">
+                    <a:solidFill>
+                      <a:srgbClr val="FFFFFF"/>
+                    </a:solidFill>
+                  </a:tcPr>
+                </a:tc>
+                <a:tc>
+                  <a:txBody>
+                    <a:bodyPr/>
+                    <a:lstStyle/>
+                    <a:p>
+                      <a:pPr algn="ctr"/>
+                      <a:r>
+                        <a:rPr sz="1000" b="0">
+                          <a:solidFill>
+                            <a:srgbClr val="1E293B"/>
+                          </a:solidFill>
+                        </a:rPr>
+                        <a:t>local</a:t>
+                      </a:r>
+                    </a:p>
+                  </a:txBody>
+                  <a:tcPr anchor="ctr">
+                    <a:solidFill>
+                      <a:srgbClr val="FFFFFF"/>
+                    </a:solidFill>
+                  </a:tcPr>
+                </a:tc>
+                <a:tc>
+                  <a:txBody>
+                    <a:bodyPr/>
+                    <a:lstStyle/>
+                    <a:p>
+                      <a:pPr algn="ctr"/>
+                      <a:r>
+                        <a:rPr sz="1000" b="0">
+                          <a:solidFill>
+                            <a:srgbClr val="1E293B"/>
+                          </a:solidFill>
+                        </a:rPr>
+                        <a:t>—</a:t>
+                      </a:r>
+                    </a:p>
+                  </a:txBody>
+                  <a:tcPr anchor="ctr">
+                    <a:solidFill>
+                      <a:srgbClr val="FFFFFF"/>
+                    </a:solidFill>
+                  </a:tcPr>
+                </a:tc>
+                <a:tc>
+                  <a:txBody>
+                    <a:bodyPr/>
+                    <a:lstStyle/>
+                    <a:p>
+                      <a:pPr algn="ctr"/>
+                      <a:r>
+                        <a:rPr sz="1000" b="0">
+                          <a:solidFill>
+                            <a:srgbClr val="1E293B"/>
+                          </a:solidFill>
+                        </a:rPr>
+                        <a:t>local (nrUE)</a:t>
+                      </a:r>
+                    </a:p>
+                  </a:txBody>
+                  <a:tcPr anchor="ctr">
+                    <a:solidFill>
+                      <a:srgbClr val="FFFFFF"/>
+                    </a:solidFill>
+                  </a:tcPr>
+                </a:tc>
+              </a:tr>
+              <a:tr h="365760">
+                <a:tc>
+                  <a:txBody>
+                    <a:bodyPr/>
+                    <a:lstStyle/>
+                    <a:p>
+                      <a:pPr algn="l"/>
+                      <a:r>
+                        <a:rPr sz="1000" b="0">
+                          <a:solidFill>
+                            <a:srgbClr val="1E293B"/>
+                          </a:solidFill>
+                        </a:rPr>
+                        <a:t>Uu</a:t>
+                      </a:r>
+                    </a:p>
+                  </a:txBody>
+                  <a:tcPr anchor="ctr">
+                    <a:solidFill>
+                      <a:srgbClr val="F4F8FC"/>
+                    </a:solidFill>
+                  </a:tcPr>
+                </a:tc>
+                <a:tc>
+                  <a:txBody>
+                    <a:bodyPr/>
+                    <a:lstStyle/>
+                    <a:p>
+                      <a:pPr algn="ctr"/>
+                      <a:r>
+                        <a:rPr sz="1000" b="0">
+                          <a:solidFill>
+                            <a:srgbClr val="1E293B"/>
+                          </a:solidFill>
+                        </a:rPr>
+                        <a:t>RFSIM</a:t>
+                      </a:r>
+                    </a:p>
+                  </a:txBody>
+                  <a:tcPr anchor="ctr">
+                    <a:solidFill>
+                      <a:srgbClr val="F4F8FC"/>
+                    </a:solidFill>
+                  </a:tcPr>
+                </a:tc>
+                <a:tc>
+                  <a:txBody>
+                    <a:bodyPr/>
+                    <a:lstStyle/>
+                    <a:p>
+                      <a:pPr algn="ctr"/>
+                      <a:r>
+                        <a:rPr sz="1000" b="0">
+                          <a:solidFill>
+                            <a:srgbClr val="1E293B"/>
+                          </a:solidFill>
+                        </a:rPr>
+                        <a:t>2</a:t>
+                      </a:r>
+                    </a:p>
+                  </a:txBody>
+                  <a:tcPr anchor="ctr">
+                    <a:solidFill>
+                      <a:srgbClr val="F4F8FC"/>
+                    </a:solidFill>
+                  </a:tcPr>
+                </a:tc>
+                <a:tc>
+                  <a:txBody>
+                    <a:bodyPr/>
+                    <a:lstStyle/>
+                    <a:p>
+                      <a:pPr algn="ctr"/>
+                      <a:r>
+                        <a:rPr sz="1000" b="0">
+                          <a:solidFill>
+                            <a:srgbClr val="1E293B"/>
+                          </a:solidFill>
+                        </a:rPr>
+                        <a:t>local</a:t>
+                      </a:r>
+                    </a:p>
+                  </a:txBody>
+                  <a:tcPr anchor="ctr">
+                    <a:solidFill>
+                      <a:srgbClr val="F4F8FC"/>
+                    </a:solidFill>
+                  </a:tcPr>
+                </a:tc>
+                <a:tc>
+                  <a:txBody>
+                    <a:bodyPr/>
+                    <a:lstStyle/>
+                    <a:p>
+                      <a:pPr algn="ctr"/>
+                      <a:r>
+                        <a:rPr sz="1000" b="0">
+                          <a:solidFill>
+                            <a:srgbClr val="1E293B"/>
+                          </a:solidFill>
+                        </a:rPr>
+                        <a:t>—</a:t>
+                      </a:r>
+                    </a:p>
+                  </a:txBody>
+                  <a:tcPr anchor="ctr">
+                    <a:solidFill>
+                      <a:srgbClr val="F4F8FC"/>
+                    </a:solidFill>
+                  </a:tcPr>
+                </a:tc>
+                <a:tc>
+                  <a:txBody>
+                    <a:bodyPr/>
+                    <a:lstStyle/>
+                    <a:p>
+                      <a:pPr algn="ctr"/>
+                      <a:r>
+                        <a:rPr sz="1000" b="0">
+                          <a:solidFill>
+                            <a:srgbClr val="1E293B"/>
+                          </a:solidFill>
+                        </a:rPr>
+                        <a:t>nr_ue (nrUE)</a:t>
+                      </a:r>
+                    </a:p>
+                  </a:txBody>
+                  <a:tcPr anchor="ctr">
+                    <a:solidFill>
+                      <a:srgbClr val="F4F8FC"/>
+                    </a:solidFill>
+                  </a:tcPr>
+                </a:tc>
+              </a:tr>
+              <a:tr h="365760">
+                <a:tc>
+                  <a:txBody>
+                    <a:bodyPr/>
+                    <a:lstStyle/>
+                    <a:p>
+                      <a:pPr algn="l"/>
+                      <a:r>
+                        <a:rPr sz="1000" b="0">
+                          <a:solidFill>
+                            <a:srgbClr val="1E293B"/>
+                          </a:solidFill>
+                        </a:rPr>
+                        <a:t>Uu</a:t>
+                      </a:r>
+                    </a:p>
+                  </a:txBody>
+                  <a:tcPr anchor="ctr">
+                    <a:solidFill>
+                      <a:srgbClr val="FFFFFF"/>
+                    </a:solidFill>
+                  </a:tcPr>
+                </a:tc>
+                <a:tc>
+                  <a:txBody>
+                    <a:bodyPr/>
+                    <a:lstStyle/>
+                    <a:p>
+                      <a:pPr algn="ctr"/>
+                      <a:r>
+                        <a:rPr sz="1000" b="0">
+                          <a:solidFill>
+                            <a:srgbClr val="1E293B"/>
+                          </a:solidFill>
+                        </a:rPr>
                         <a:t>USRP</a:t>
                       </a:r>
                     </a:p>
@@ -8446,6 +8737,140 @@
                   <a:tcPr anchor="ctr">
                     <a:solidFill>
                       <a:srgbClr val="FFFFFF"/>
+                    </a:solidFill>
+                  </a:tcPr>
+                </a:tc>
+              </a:tr>
+              <a:tr h="365760">
+                <a:tc>
+                  <a:txBody>
+                    <a:bodyPr/>
+                    <a:lstStyle/>
+                    <a:p>
+                      <a:pPr algn="l"/>
+                      <a:r>
+                        <a:rPr sz="1000" b="0">
+                          <a:solidFill>
+                            <a:srgbClr val="1E293B"/>
+                          </a:solidFill>
+                        </a:rPr>
+                        <a:t>Uu</a:t>
+                      </a:r>
+                    </a:p>
+                  </a:txBody>
+                  <a:tcPr anchor="ctr">
+                    <a:solidFill>
+                      <a:srgbClr val="F4F8FC"/>
+                    </a:solidFill>
+                  </a:tcPr>
+                </a:tc>
+                <a:tc>
+                  <a:txBody>
+                    <a:bodyPr/>
+                    <a:lstStyle/>
+                    <a:p>
+                      <a:pPr algn="ctr"/>
+                      <a:r>
+                        <a:rPr sz="1000" b="0">
+                          <a:solidFill>
+                            <a:srgbClr val="1E293B"/>
+                          </a:solidFill>
+                        </a:rPr>
+                        <a:t>VRTSIM</a:t>
+                      </a:r>
+                    </a:p>
+                  </a:txBody>
+                  <a:tcPr anchor="ctr">
+                    <a:solidFill>
+                      <a:srgbClr val="F4F8FC"/>
+                    </a:solidFill>
+                  </a:tcPr>
+                </a:tc>
+                <a:tc>
+                  <a:txBody>
+                    <a:bodyPr/>
+                    <a:lstStyle/>
+                    <a:p>
+                      <a:pPr algn="ctr"/>
+                      <a:r>
+                        <a:rPr sz="1000" b="0">
+                          <a:solidFill>
+                            <a:srgbClr val="1E293B"/>
+                          </a:solidFill>
+                        </a:rPr>
+                        <a:t>1</a:t>
+                      </a:r>
+                    </a:p>
+                  </a:txBody>
+                  <a:tcPr anchor="ctr">
+                    <a:solidFill>
+                      <a:srgbClr val="F4F8FC"/>
+                    </a:solidFill>
+                  </a:tcPr>
+                </a:tc>
+                <a:tc>
+                  <a:txBody>
+                    <a:bodyPr/>
+                    <a:lstStyle/>
+                    <a:p>
+                      <a:pPr algn="ctr"/>
+                      <a:r>
+                        <a:rPr sz="1000" b="0">
+                          <a:solidFill>
+                            <a:srgbClr val="1E293B"/>
+                          </a:solidFill>
+                        </a:rPr>
+                        <a:t>local</a:t>
+                      </a:r>
+                    </a:p>
+                  </a:txBody>
+                  <a:tcPr anchor="ctr">
+                    <a:solidFill>
+                      <a:srgbClr val="F4F8FC"/>
+                    </a:solidFill>
+                  </a:tcPr>
+                </a:tc>
+                <a:tc>
+                  <a:txBody>
+                    <a:bodyPr/>
+                    <a:lstStyle/>
+                    <a:p>
+                      <a:pPr algn="ctr"/>
+                      <a:r>
+                        <a:rPr sz="1000" b="0">
+                          <a:solidFill>
+                            <a:srgbClr val="1E293B"/>
+                          </a:solidFill>
+                        </a:rPr>
+                        <a:t>—</a:t>
+                      </a:r>
+                    </a:p>
+                  </a:txBody>
+                  <a:tcPr anchor="ctr">
+                    <a:solidFill>
+                      <a:srgbClr val="F4F8FC"/>
+                    </a:solidFill>
+                  </a:tcPr>
+                </a:tc>
+                <a:tc>
+                  <a:txBody>
+                    <a:bodyPr/>
+                    <a:lstStyle/>
+                    <a:p>
+                      <a:pPr algn="ctr"/>
+                      <a:r>
+                        <a:rPr sz="1000" b="0">
+                          <a:solidFill>
+                            <a:srgbClr val="1E293B"/>
+                          </a:solidFill>
+                        </a:rPr>
+                        <a:t>local (nrUE)</a:t>
+                      </a:r>
+                    </a:p>
+                  </a:txBody>
+                  <a:tcPr anchor="ctr">
+                    <a:solidFill>
+                      <a:srgbClr val="F4F8FC"/>
                     </a:solidFill>
                   </a:tcPr>
                 </a:tc>
@@ -9780,7 +10205,7 @@
               </a:spcAft>
             </a:pPr>
             <a:r>
-              <a:rPr sz="1100">
+              <a:rPr sz="900">
                 <a:solidFill>
                   <a:srgbClr val="E2E8F0"/>
                 </a:solidFill>
@@ -9796,7 +10221,7 @@
               </a:spcAft>
             </a:pPr>
             <a:r>
-              <a:rPr sz="1100">
+              <a:rPr sz="900">
                 <a:solidFill>
                   <a:srgbClr val="E2E8F0"/>
                 </a:solidFill>
@@ -9812,7 +10237,7 @@
               </a:spcAft>
             </a:pPr>
             <a:r>
-              <a:rPr sz="1100">
+              <a:rPr sz="900">
                 <a:solidFill>
                   <a:srgbClr val="E2E8F0"/>
                 </a:solidFill>
@@ -9828,7 +10253,7 @@
               </a:spcAft>
             </a:pPr>
             <a:r>
-              <a:rPr sz="1100">
+              <a:rPr sz="900">
                 <a:solidFill>
                   <a:srgbClr val="E2E8F0"/>
                 </a:solidFill>
@@ -9844,7 +10269,7 @@
               </a:spcAft>
             </a:pPr>
             <a:r>
-              <a:rPr sz="1100">
+              <a:rPr sz="900">
                 <a:solidFill>
                   <a:srgbClr val="E2E8F0"/>
                 </a:solidFill>
@@ -9860,7 +10285,7 @@
               </a:spcAft>
             </a:pPr>
             <a:r>
-              <a:rPr sz="1100">
+              <a:rPr sz="900">
                 <a:solidFill>
                   <a:srgbClr val="E2E8F0"/>
                 </a:solidFill>
@@ -9876,7 +10301,7 @@
               </a:spcAft>
             </a:pPr>
             <a:r>
-              <a:rPr sz="1100">
+              <a:rPr sz="900">
                 <a:solidFill>
                   <a:srgbClr val="E2E8F0"/>
                 </a:solidFill>
@@ -9892,7 +10317,7 @@
               </a:spcAft>
             </a:pPr>
             <a:r>
-              <a:rPr sz="1100">
+              <a:rPr sz="900">
                 <a:solidFill>
                   <a:srgbClr val="E2E8F0"/>
                 </a:solidFill>
@@ -9908,7 +10333,7 @@
               </a:spcAft>
             </a:pPr>
             <a:r>
-              <a:rPr sz="1100">
+              <a:rPr sz="900">
                 <a:solidFill>
                   <a:srgbClr val="E2E8F0"/>
                 </a:solidFill>
@@ -9924,7 +10349,7 @@
               </a:spcAft>
             </a:pPr>
             <a:r>
-              <a:rPr sz="1100">
+              <a:rPr sz="900">
                 <a:solidFill>
                   <a:srgbClr val="E2E8F0"/>
                 </a:solidFill>
@@ -9940,7 +10365,7 @@
               </a:spcAft>
             </a:pPr>
             <a:r>
-              <a:rPr sz="1100">
+              <a:rPr sz="900">
                 <a:solidFill>
                   <a:srgbClr val="E2E8F0"/>
                 </a:solidFill>
@@ -9956,7 +10381,7 @@
               </a:spcAft>
             </a:pPr>
             <a:r>
-              <a:rPr sz="1100">
+              <a:rPr sz="900">
                 <a:solidFill>
                   <a:srgbClr val="E2E8F0"/>
                 </a:solidFill>
@@ -9972,7 +10397,7 @@
               </a:spcAft>
             </a:pPr>
             <a:r>
-              <a:rPr sz="1100">
+              <a:rPr sz="900">
                 <a:solidFill>
                   <a:srgbClr val="E2E8F0"/>
                 </a:solidFill>
@@ -9988,7 +10413,7 @@
               </a:spcAft>
             </a:pPr>
             <a:r>
-              <a:rPr sz="1100">
+              <a:rPr sz="900">
                 <a:solidFill>
                   <a:srgbClr val="E2E8F0"/>
                 </a:solidFill>
@@ -10004,7 +10429,7 @@
               </a:spcAft>
             </a:pPr>
             <a:r>
-              <a:rPr sz="1100">
+              <a:rPr sz="900">
                 <a:solidFill>
                   <a:srgbClr val="E2E8F0"/>
                 </a:solidFill>
@@ -12950,7 +13375,7 @@
         </p:nvGraphicFramePr>
         <p:xfrm>
           <a:off x="548640" y="777240"/>
-          <a:ext cx="10972800" cy="2514600"/>
+          <a:ext cx="10972800" cy="3200400"/>
         </p:xfrm>
         <a:graphic>
           <a:graphicData uri="http://schemas.openxmlformats.org/drawingml/2006/table">
@@ -13950,6 +14375,276 @@
                   <a:tcPr anchor="ctr">
                     <a:solidFill>
                       <a:srgbClr val="F4F8FC"/>
+                    </a:solidFill>
+                  </a:tcPr>
+                </a:tc>
+              </a:tr>
+              <a:tr h="228600">
+                <a:tc>
+                  <a:txBody>
+                    <a:bodyPr/>
+                    <a:lstStyle/>
+                    <a:p>
+                      <a:pPr algn="l"/>
+                      <a:r>
+                        <a:rPr sz="1000" b="0">
+                          <a:solidFill>
+                            <a:srgbClr val="1E293B"/>
+                          </a:solidFill>
+                        </a:rPr>
+                        <a:t>vrtsim_uu_ping_test_on_local_host</a:t>
+                      </a:r>
+                    </a:p>
+                  </a:txBody>
+                  <a:tcPr anchor="ctr">
+                    <a:solidFill>
+                      <a:srgbClr val="FFFFFF"/>
+                    </a:solidFill>
+                  </a:tcPr>
+                </a:tc>
+                <a:tc>
+                  <a:txBody>
+                    <a:bodyPr/>
+                    <a:lstStyle/>
+                    <a:p>
+                      <a:pPr algn="ctr"/>
+                      <a:r>
+                        <a:rPr sz="1000" b="0">
+                          <a:solidFill>
+                            <a:srgbClr val="1E293B"/>
+                          </a:solidFill>
+                        </a:rPr>
+                        <a:t>Uu</a:t>
+                      </a:r>
+                    </a:p>
+                  </a:txBody>
+                  <a:tcPr anchor="ctr">
+                    <a:solidFill>
+                      <a:srgbClr val="FFFFFF"/>
+                    </a:solidFill>
+                  </a:tcPr>
+                </a:tc>
+                <a:tc>
+                  <a:txBody>
+                    <a:bodyPr/>
+                    <a:lstStyle/>
+                    <a:p>
+                      <a:pPr algn="ctr"/>
+                      <a:r>
+                        <a:rPr sz="1000" b="0">
+                          <a:solidFill>
+                            <a:srgbClr val="1E293B"/>
+                          </a:solidFill>
+                        </a:rPr>
+                        <a:t>1</a:t>
+                      </a:r>
+                    </a:p>
+                  </a:txBody>
+                  <a:tcPr anchor="ctr">
+                    <a:solidFill>
+                      <a:srgbClr val="FFFFFF"/>
+                    </a:solidFill>
+                  </a:tcPr>
+                </a:tc>
+                <a:tc>
+                  <a:txBody>
+                    <a:bodyPr/>
+                    <a:lstStyle/>
+                    <a:p>
+                      <a:pPr algn="l"/>
+                      <a:r>
+                        <a:rPr sz="1000" b="0">
+                          <a:solidFill>
+                            <a:srgbClr val="1E293B"/>
+                          </a:solidFill>
+                        </a:rPr>
+                        <a:t>gNB &lt;-&gt; UE ping over shared-memory radio</a:t>
+                      </a:r>
+                    </a:p>
+                  </a:txBody>
+                  <a:tcPr anchor="ctr">
+                    <a:solidFill>
+                      <a:srgbClr val="FFFFFF"/>
+                    </a:solidFill>
+                  </a:tcPr>
+                </a:tc>
+              </a:tr>
+              <a:tr h="228600">
+                <a:tc>
+                  <a:txBody>
+                    <a:bodyPr/>
+                    <a:lstStyle/>
+                    <a:p>
+                      <a:pPr algn="l"/>
+                      <a:r>
+                        <a:rPr sz="1000" b="0">
+                          <a:solidFill>
+                            <a:srgbClr val="1E293B"/>
+                          </a:solidFill>
+                        </a:rPr>
+                        <a:t>vrtsim_pc5_ping_test_on_local_host</a:t>
+                      </a:r>
+                    </a:p>
+                  </a:txBody>
+                  <a:tcPr anchor="ctr">
+                    <a:solidFill>
+                      <a:srgbClr val="F4F8FC"/>
+                    </a:solidFill>
+                  </a:tcPr>
+                </a:tc>
+                <a:tc>
+                  <a:txBody>
+                    <a:bodyPr/>
+                    <a:lstStyle/>
+                    <a:p>
+                      <a:pPr algn="ctr"/>
+                      <a:r>
+                        <a:rPr sz="1000" b="0">
+                          <a:solidFill>
+                            <a:srgbClr val="1E293B"/>
+                          </a:solidFill>
+                        </a:rPr>
+                        <a:t>SL Mode 2</a:t>
+                      </a:r>
+                    </a:p>
+                  </a:txBody>
+                  <a:tcPr anchor="ctr">
+                    <a:solidFill>
+                      <a:srgbClr val="F4F8FC"/>
+                    </a:solidFill>
+                  </a:tcPr>
+                </a:tc>
+                <a:tc>
+                  <a:txBody>
+                    <a:bodyPr/>
+                    <a:lstStyle/>
+                    <a:p>
+                      <a:pPr algn="ctr"/>
+                      <a:r>
+                        <a:rPr sz="1000" b="0">
+                          <a:solidFill>
+                            <a:srgbClr val="1E293B"/>
+                          </a:solidFill>
+                        </a:rPr>
+                        <a:t>1</a:t>
+                      </a:r>
+                    </a:p>
+                  </a:txBody>
+                  <a:tcPr anchor="ctr">
+                    <a:solidFill>
+                      <a:srgbClr val="F4F8FC"/>
+                    </a:solidFill>
+                  </a:tcPr>
+                </a:tc>
+                <a:tc>
+                  <a:txBody>
+                    <a:bodyPr/>
+                    <a:lstStyle/>
+                    <a:p>
+                      <a:pPr algn="l"/>
+                      <a:r>
+                        <a:rPr sz="1000" b="0">
+                          <a:solidFill>
+                            <a:srgbClr val="1E293B"/>
+                          </a:solidFill>
+                        </a:rPr>
+                        <a:t>PC5 ping over shared-memory radio</a:t>
+                      </a:r>
+                    </a:p>
+                  </a:txBody>
+                  <a:tcPr anchor="ctr">
+                    <a:solidFill>
+                      <a:srgbClr val="F4F8FC"/>
+                    </a:solidFill>
+                  </a:tcPr>
+                </a:tc>
+              </a:tr>
+              <a:tr h="228600">
+                <a:tc>
+                  <a:txBody>
+                    <a:bodyPr/>
+                    <a:lstStyle/>
+                    <a:p>
+                      <a:pPr algn="l"/>
+                      <a:r>
+                        <a:rPr sz="1000" b="0">
+                          <a:solidFill>
+                            <a:srgbClr val="1E293B"/>
+                          </a:solidFill>
+                        </a:rPr>
+                        <a:t>vrtsim_slmode1_srap_ping_test_on_local_host</a:t>
+                      </a:r>
+                    </a:p>
+                  </a:txBody>
+                  <a:tcPr anchor="ctr">
+                    <a:solidFill>
+                      <a:srgbClr val="FFFFFF"/>
+                    </a:solidFill>
+                  </a:tcPr>
+                </a:tc>
+                <a:tc>
+                  <a:txBody>
+                    <a:bodyPr/>
+                    <a:lstStyle/>
+                    <a:p>
+                      <a:pPr algn="ctr"/>
+                      <a:r>
+                        <a:rPr sz="1000" b="0">
+                          <a:solidFill>
+                            <a:srgbClr val="1E293B"/>
+                          </a:solidFill>
+                        </a:rPr>
+                        <a:t>SL Mode 1</a:t>
+                      </a:r>
+                    </a:p>
+                  </a:txBody>
+                  <a:tcPr anchor="ctr">
+                    <a:solidFill>
+                      <a:srgbClr val="FFFFFF"/>
+                    </a:solidFill>
+                  </a:tcPr>
+                </a:tc>
+                <a:tc>
+                  <a:txBody>
+                    <a:bodyPr/>
+                    <a:lstStyle/>
+                    <a:p>
+                      <a:pPr algn="ctr"/>
+                      <a:r>
+                        <a:rPr sz="1000" b="0">
+                          <a:solidFill>
+                            <a:srgbClr val="1E293B"/>
+                          </a:solidFill>
+                        </a:rPr>
+                        <a:t>1</a:t>
+                      </a:r>
+                    </a:p>
+                  </a:txBody>
+                  <a:tcPr anchor="ctr">
+                    <a:solidFill>
+                      <a:srgbClr val="FFFFFF"/>
+                    </a:solidFill>
+                  </a:tcPr>
+                </a:tc>
+                <a:tc>
+                  <a:txBody>
+                    <a:bodyPr/>
+                    <a:lstStyle/>
+                    <a:p>
+                      <a:pPr algn="l"/>
+                      <a:r>
+                        <a:rPr sz="1000" b="0">
+                          <a:solidFill>
+                            <a:srgbClr val="1E293B"/>
+                          </a:solidFill>
+                        </a:rPr>
+                        <a:t>U2N relay ping (SRAP) over shared-memory radio; launch-order/timing sensitive</a:t>
+                      </a:r>
+                    </a:p>
+                  </a:txBody>
+                  <a:tcPr anchor="ctr">
+                    <a:solidFill>
+                      <a:srgbClr val="FFFFFF"/>
                     </a:solidFill>
                   </a:tcPr>
                 </a:tc>

</xml_diff>

<commit_message>
Add VRTSim local-host sidelink tests and fix SL Mode 1 iperf3 bind
</commit_message>
<xml_diff>
--- a/doc/episys/test_script/overview_sl_test.pptx
+++ b/doc/episys/test_script/overview_sl_test.pptx
@@ -11385,7 +11385,7 @@
         </p:nvGraphicFramePr>
         <p:xfrm>
           <a:off x="548640" y="777240"/>
-          <a:ext cx="5943600" cy="2414015"/>
+          <a:ext cx="5943600" cy="3182112"/>
         </p:xfrm>
         <a:graphic>
           <a:graphicData uri="http://schemas.openxmlformats.org/drawingml/2006/table">
@@ -11398,7 +11398,7 @@
                 <a:gridCol w="457200"/>
                 <a:gridCol w="3657600"/>
               </a:tblGrid>
-              <a:tr h="109727">
+              <a:tr h="109728">
                 <a:tc>
                   <a:txBody>
                     <a:bodyPr/>
@@ -11466,7 +11466,7 @@
                   </a:tcPr>
                 </a:tc>
               </a:tr>
-              <a:tr h="109727">
+              <a:tr h="109728">
                 <a:tc>
                   <a:txBody>
                     <a:bodyPr/>
@@ -11534,7 +11534,7 @@
                   </a:tcPr>
                 </a:tc>
               </a:tr>
-              <a:tr h="109727">
+              <a:tr h="109728">
                 <a:tc>
                   <a:txBody>
                     <a:bodyPr/>
@@ -11591,18 +11591,154 @@
                             <a:srgbClr val="1E293B"/>
                           </a:solidFill>
                         </a:rPr>
+                        <a:t>vrtsim_uu_ping_test_on_local_host</a:t>
+                      </a:r>
+                    </a:p>
+                  </a:txBody>
+                  <a:tcPr anchor="ctr">
+                    <a:solidFill>
+                      <a:srgbClr val="F4F8FC"/>
+                    </a:solidFill>
+                  </a:tcPr>
+                </a:tc>
+              </a:tr>
+              <a:tr h="109728">
+                <a:tc>
+                  <a:txBody>
+                    <a:bodyPr/>
+                    <a:lstStyle/>
+                    <a:p>
+                      <a:pPr algn="l"/>
+                      <a:r>
+                        <a:rPr sz="1000" b="0">
+                          <a:solidFill>
+                            <a:srgbClr val="1E293B"/>
+                          </a:solidFill>
+                        </a:rPr>
+                        <a:t/>
+                      </a:r>
+                    </a:p>
+                  </a:txBody>
+                  <a:tcPr anchor="ctr">
+                    <a:solidFill>
+                      <a:srgbClr val="FFFFFF"/>
+                    </a:solidFill>
+                  </a:tcPr>
+                </a:tc>
+                <a:tc>
+                  <a:txBody>
+                    <a:bodyPr/>
+                    <a:lstStyle/>
+                    <a:p>
+                      <a:pPr algn="ctr"/>
+                      <a:r>
+                        <a:rPr sz="1000" b="0">
+                          <a:solidFill>
+                            <a:srgbClr val="1E293B"/>
+                          </a:solidFill>
+                        </a:rPr>
+                        <a:t>2</a:t>
+                      </a:r>
+                    </a:p>
+                  </a:txBody>
+                  <a:tcPr anchor="ctr">
+                    <a:solidFill>
+                      <a:srgbClr val="FFFFFF"/>
+                    </a:solidFill>
+                  </a:tcPr>
+                </a:tc>
+                <a:tc>
+                  <a:txBody>
+                    <a:bodyPr/>
+                    <a:lstStyle/>
+                    <a:p>
+                      <a:pPr algn="l"/>
+                      <a:r>
+                        <a:rPr sz="1000" b="0">
+                          <a:solidFill>
+                            <a:srgbClr val="1E293B"/>
+                          </a:solidFill>
+                        </a:rPr>
                         <a:t>rfsim_uu_ping_test_on_two_hosts</a:t>
                       </a:r>
                     </a:p>
                   </a:txBody>
                   <a:tcPr anchor="ctr">
                     <a:solidFill>
+                      <a:srgbClr val="FFFFFF"/>
+                    </a:solidFill>
+                  </a:tcPr>
+                </a:tc>
+              </a:tr>
+              <a:tr h="109728">
+                <a:tc>
+                  <a:txBody>
+                    <a:bodyPr/>
+                    <a:lstStyle/>
+                    <a:p>
+                      <a:pPr algn="l"/>
+                      <a:r>
+                        <a:rPr sz="1000" b="0">
+                          <a:solidFill>
+                            <a:srgbClr val="1E293B"/>
+                          </a:solidFill>
+                        </a:rPr>
+                        <a:t/>
+                      </a:r>
+                    </a:p>
+                  </a:txBody>
+                  <a:tcPr anchor="ctr">
+                    <a:solidFill>
                       <a:srgbClr val="F4F8FC"/>
                     </a:solidFill>
                   </a:tcPr>
                 </a:tc>
+                <a:tc>
+                  <a:txBody>
+                    <a:bodyPr/>
+                    <a:lstStyle/>
+                    <a:p>
+                      <a:pPr algn="ctr"/>
+                      <a:r>
+                        <a:rPr sz="1000" b="0">
+                          <a:solidFill>
+                            <a:srgbClr val="1E293B"/>
+                          </a:solidFill>
+                        </a:rPr>
+                        <a:t>3</a:t>
+                      </a:r>
+                    </a:p>
+                  </a:txBody>
+                  <a:tcPr anchor="ctr">
+                    <a:solidFill>
+                      <a:srgbClr val="F4F8FC"/>
+                    </a:solidFill>
+                  </a:tcPr>
+                </a:tc>
+                <a:tc>
+                  <a:txBody>
+                    <a:bodyPr/>
+                    <a:lstStyle/>
+                    <a:p>
+                      <a:pPr algn="l"/>
+                      <a:r>
+                        <a:rPr sz="1000" b="0">
+                          <a:solidFill>
+                            <a:srgbClr val="1E293B"/>
+                          </a:solidFill>
+                        </a:rPr>
+                        <a:t>usrp_B210_uu_ping_test_on_two_hosts</a:t>
+                      </a:r>
+                    </a:p>
+                  </a:txBody>
+                  <a:tcPr anchor="ctr">
+                    <a:solidFill>
+                      <a:srgbClr val="F4F8FC"/>
+                    </a:solidFill>
+                  </a:tcPr>
+                </a:tc>
               </a:tr>
-              <a:tr h="109727">
+              <a:tr h="109728">
                 <a:tc>
                   <a:txBody>
                     <a:bodyPr/>
@@ -11615,12 +11751,148 @@
                             <a:srgbClr val="1E293B"/>
                           </a:solidFill>
                         </a:rPr>
+                        <a:t>slmode2_basic_tests</a:t>
+                      </a:r>
+                    </a:p>
+                  </a:txBody>
+                  <a:tcPr anchor="ctr">
+                    <a:solidFill>
+                      <a:srgbClr val="FFFFFF"/>
+                    </a:solidFill>
+                  </a:tcPr>
+                </a:tc>
+                <a:tc>
+                  <a:txBody>
+                    <a:bodyPr/>
+                    <a:lstStyle/>
+                    <a:p>
+                      <a:pPr algn="ctr"/>
+                      <a:r>
+                        <a:rPr sz="1000" b="0">
+                          <a:solidFill>
+                            <a:srgbClr val="1E293B"/>
+                          </a:solidFill>
+                        </a:rPr>
+                        <a:t>0</a:t>
+                      </a:r>
+                    </a:p>
+                  </a:txBody>
+                  <a:tcPr anchor="ctr">
+                    <a:solidFill>
+                      <a:srgbClr val="FFFFFF"/>
+                    </a:solidFill>
+                  </a:tcPr>
+                </a:tc>
+                <a:tc>
+                  <a:txBody>
+                    <a:bodyPr/>
+                    <a:lstStyle/>
+                    <a:p>
+                      <a:pPr algn="l"/>
+                      <a:r>
+                        <a:rPr sz="1000" b="0">
+                          <a:solidFill>
+                            <a:srgbClr val="1E293B"/>
+                          </a:solidFill>
+                        </a:rPr>
+                        <a:t>rfsim_pc5_ping_test_on_local_host</a:t>
+                      </a:r>
+                    </a:p>
+                  </a:txBody>
+                  <a:tcPr anchor="ctr">
+                    <a:solidFill>
+                      <a:srgbClr val="FFFFFF"/>
+                    </a:solidFill>
+                  </a:tcPr>
+                </a:tc>
+              </a:tr>
+              <a:tr h="109728">
+                <a:tc>
+                  <a:txBody>
+                    <a:bodyPr/>
+                    <a:lstStyle/>
+                    <a:p>
+                      <a:pPr algn="l"/>
+                      <a:r>
+                        <a:rPr sz="1000" b="0">
+                          <a:solidFill>
+                            <a:srgbClr val="1E293B"/>
+                          </a:solidFill>
+                        </a:rPr>
                         <a:t/>
                       </a:r>
                     </a:p>
                   </a:txBody>
                   <a:tcPr anchor="ctr">
                     <a:solidFill>
+                      <a:srgbClr val="F4F8FC"/>
+                    </a:solidFill>
+                  </a:tcPr>
+                </a:tc>
+                <a:tc>
+                  <a:txBody>
+                    <a:bodyPr/>
+                    <a:lstStyle/>
+                    <a:p>
+                      <a:pPr algn="ctr"/>
+                      <a:r>
+                        <a:rPr sz="1000" b="0">
+                          <a:solidFill>
+                            <a:srgbClr val="1E293B"/>
+                          </a:solidFill>
+                        </a:rPr>
+                        <a:t>1</a:t>
+                      </a:r>
+                    </a:p>
+                  </a:txBody>
+                  <a:tcPr anchor="ctr">
+                    <a:solidFill>
+                      <a:srgbClr val="F4F8FC"/>
+                    </a:solidFill>
+                  </a:tcPr>
+                </a:tc>
+                <a:tc>
+                  <a:txBody>
+                    <a:bodyPr/>
+                    <a:lstStyle/>
+                    <a:p>
+                      <a:pPr algn="l"/>
+                      <a:r>
+                        <a:rPr sz="1000" b="0">
+                          <a:solidFill>
+                            <a:srgbClr val="1E293B"/>
+                          </a:solidFill>
+                        </a:rPr>
+                        <a:t>vrtsim_pc5_ping_test_on_local_host</a:t>
+                      </a:r>
+                    </a:p>
+                  </a:txBody>
+                  <a:tcPr anchor="ctr">
+                    <a:solidFill>
+                      <a:srgbClr val="F4F8FC"/>
+                    </a:solidFill>
+                  </a:tcPr>
+                </a:tc>
+              </a:tr>
+              <a:tr h="109728">
+                <a:tc>
+                  <a:txBody>
+                    <a:bodyPr/>
+                    <a:lstStyle/>
+                    <a:p>
+                      <a:pPr algn="l"/>
+                      <a:r>
+                        <a:rPr sz="1000" b="0">
+                          <a:solidFill>
+                            <a:srgbClr val="1E293B"/>
+                          </a:solidFill>
+                        </a:rPr>
+                        <a:t/>
+                      </a:r>
+                    </a:p>
+                  </a:txBody>
+                  <a:tcPr anchor="ctr">
+                    <a:solidFill>
                       <a:srgbClr val="FFFFFF"/>
                     </a:solidFill>
                   </a:tcPr>
@@ -11659,7 +11931,7 @@
                             <a:srgbClr val="1E293B"/>
                           </a:solidFill>
                         </a:rPr>
-                        <a:t>usrp_B210_uu_ping_test_on_two_hosts</a:t>
+                        <a:t>rfsim_pc5_ping_test_on_two_hosts</a:t>
                       </a:r>
                     </a:p>
                   </a:txBody>
@@ -11670,7 +11942,7 @@
                   </a:tcPr>
                 </a:tc>
               </a:tr>
-              <a:tr h="109727">
+              <a:tr h="109728">
                 <a:tc>
                   <a:txBody>
                     <a:bodyPr/>
@@ -11683,7 +11955,7 @@
                             <a:srgbClr val="1E293B"/>
                           </a:solidFill>
                         </a:rPr>
-                        <a:t>slmode2_basic_tests</a:t>
+                        <a:t/>
                       </a:r>
                     </a:p>
                   </a:txBody>
@@ -11705,12 +11977,126 @@
                             <a:srgbClr val="1E293B"/>
                           </a:solidFill>
                         </a:rPr>
+                        <a:t>3</a:t>
+                      </a:r>
+                    </a:p>
+                  </a:txBody>
+                  <a:tcPr anchor="ctr">
+                    <a:solidFill>
+                      <a:srgbClr val="F4F8FC"/>
+                    </a:solidFill>
+                  </a:tcPr>
+                </a:tc>
+                <a:tc>
+                  <a:txBody>
+                    <a:bodyPr/>
+                    <a:lstStyle/>
+                    <a:p>
+                      <a:pPr algn="l"/>
+                      <a:r>
+                        <a:rPr sz="1000" b="0">
+                          <a:solidFill>
+                            <a:srgbClr val="1E293B"/>
+                          </a:solidFill>
+                        </a:rPr>
+                        <a:t>usrp_B210_pc5_ping_test_on_two_hosts</a:t>
+                      </a:r>
+                    </a:p>
+                  </a:txBody>
+                  <a:tcPr anchor="ctr">
+                    <a:solidFill>
+                      <a:srgbClr val="F4F8FC"/>
+                    </a:solidFill>
+                  </a:tcPr>
+                </a:tc>
+              </a:tr>
+              <a:tr h="109728">
+                <a:tc>
+                  <a:txBody>
+                    <a:bodyPr/>
+                    <a:lstStyle/>
+                    <a:p>
+                      <a:pPr algn="l"/>
+                      <a:r>
+                        <a:rPr sz="1000" b="0">
+                          <a:solidFill>
+                            <a:srgbClr val="1E293B"/>
+                          </a:solidFill>
+                        </a:rPr>
+                        <a:t>slmode2_csi_psfch_tests</a:t>
+                      </a:r>
+                    </a:p>
+                  </a:txBody>
+                  <a:tcPr anchor="ctr">
+                    <a:solidFill>
+                      <a:srgbClr val="FFFFFF"/>
+                    </a:solidFill>
+                  </a:tcPr>
+                </a:tc>
+                <a:tc>
+                  <a:txBody>
+                    <a:bodyPr/>
+                    <a:lstStyle/>
+                    <a:p>
+                      <a:pPr algn="ctr"/>
+                      <a:r>
+                        <a:rPr sz="1000" b="0">
+                          <a:solidFill>
+                            <a:srgbClr val="1E293B"/>
+                          </a:solidFill>
+                        </a:rPr>
                         <a:t>0</a:t>
                       </a:r>
                     </a:p>
                   </a:txBody>
                   <a:tcPr anchor="ctr">
                     <a:solidFill>
+                      <a:srgbClr val="FFFFFF"/>
+                    </a:solidFill>
+                  </a:tcPr>
+                </a:tc>
+                <a:tc>
+                  <a:txBody>
+                    <a:bodyPr/>
+                    <a:lstStyle/>
+                    <a:p>
+                      <a:pPr algn="l"/>
+                      <a:r>
+                        <a:rPr sz="1000" b="0">
+                          <a:solidFill>
+                            <a:srgbClr val="1E293B"/>
+                          </a:solidFill>
+                        </a:rPr>
+                        <a:t>rfsim_pc5_csi_acquisition_psfch_period_test_on_local_host</a:t>
+                      </a:r>
+                    </a:p>
+                  </a:txBody>
+                  <a:tcPr anchor="ctr">
+                    <a:solidFill>
+                      <a:srgbClr val="FFFFFF"/>
+                    </a:solidFill>
+                  </a:tcPr>
+                </a:tc>
+              </a:tr>
+              <a:tr h="109728">
+                <a:tc>
+                  <a:txBody>
+                    <a:bodyPr/>
+                    <a:lstStyle/>
+                    <a:p>
+                      <a:pPr algn="l"/>
+                      <a:r>
+                        <a:rPr sz="1000" b="0">
+                          <a:solidFill>
+                            <a:srgbClr val="1E293B"/>
+                          </a:solidFill>
+                        </a:rPr>
+                        <a:t/>
+                      </a:r>
+                    </a:p>
+                  </a:txBody>
+                  <a:tcPr anchor="ctr">
+                    <a:solidFill>
                       <a:srgbClr val="F4F8FC"/>
                     </a:solidFill>
                   </a:tcPr>
@@ -11720,6 +12106,28 @@
                     <a:bodyPr/>
                     <a:lstStyle/>
                     <a:p>
+                      <a:pPr algn="ctr"/>
+                      <a:r>
+                        <a:rPr sz="1000" b="0">
+                          <a:solidFill>
+                            <a:srgbClr val="1E293B"/>
+                          </a:solidFill>
+                        </a:rPr>
+                        <a:t>1</a:t>
+                      </a:r>
+                    </a:p>
+                  </a:txBody>
+                  <a:tcPr anchor="ctr">
+                    <a:solidFill>
+                      <a:srgbClr val="F4F8FC"/>
+                    </a:solidFill>
+                  </a:tcPr>
+                </a:tc>
+                <a:tc>
+                  <a:txBody>
+                    <a:bodyPr/>
+                    <a:lstStyle/>
+                    <a:p>
                       <a:pPr algn="l"/>
                       <a:r>
                         <a:rPr sz="1000" b="0">
@@ -11727,7 +12135,7 @@
                             <a:srgbClr val="1E293B"/>
                           </a:solidFill>
                         </a:rPr>
-                        <a:t>rfsim_pc5_ping_test_on_local_host</a:t>
+                        <a:t>vrtsim_pc5_csi_acquisition_psfch_period_test_on_local_host</a:t>
                       </a:r>
                     </a:p>
                   </a:txBody>
@@ -11738,7 +12146,7 @@
                   </a:tcPr>
                 </a:tc>
               </a:tr>
-              <a:tr h="109727">
+              <a:tr h="109728">
                 <a:tc>
                   <a:txBody>
                     <a:bodyPr/>
@@ -11773,12 +12181,262 @@
                             <a:srgbClr val="1E293B"/>
                           </a:solidFill>
                         </a:rPr>
+                        <a:t>2</a:t>
+                      </a:r>
+                    </a:p>
+                  </a:txBody>
+                  <a:tcPr anchor="ctr">
+                    <a:solidFill>
+                      <a:srgbClr val="FFFFFF"/>
+                    </a:solidFill>
+                  </a:tcPr>
+                </a:tc>
+                <a:tc>
+                  <a:txBody>
+                    <a:bodyPr/>
+                    <a:lstStyle/>
+                    <a:p>
+                      <a:pPr algn="l"/>
+                      <a:r>
+                        <a:rPr sz="1000" b="0">
+                          <a:solidFill>
+                            <a:srgbClr val="1E293B"/>
+                          </a:solidFill>
+                        </a:rPr>
+                        <a:t>rfsim_pc5_csi_acquisition_psfch_period_test_on_two_hosts</a:t>
+                      </a:r>
+                    </a:p>
+                  </a:txBody>
+                  <a:tcPr anchor="ctr">
+                    <a:solidFill>
+                      <a:srgbClr val="FFFFFF"/>
+                    </a:solidFill>
+                  </a:tcPr>
+                </a:tc>
+              </a:tr>
+              <a:tr h="109728">
+                <a:tc>
+                  <a:txBody>
+                    <a:bodyPr/>
+                    <a:lstStyle/>
+                    <a:p>
+                      <a:pPr algn="l"/>
+                      <a:r>
+                        <a:rPr sz="1000" b="0">
+                          <a:solidFill>
+                            <a:srgbClr val="1E293B"/>
+                          </a:solidFill>
+                        </a:rPr>
+                        <a:t/>
+                      </a:r>
+                    </a:p>
+                  </a:txBody>
+                  <a:tcPr anchor="ctr">
+                    <a:solidFill>
+                      <a:srgbClr val="F4F8FC"/>
+                    </a:solidFill>
+                  </a:tcPr>
+                </a:tc>
+                <a:tc>
+                  <a:txBody>
+                    <a:bodyPr/>
+                    <a:lstStyle/>
+                    <a:p>
+                      <a:pPr algn="ctr"/>
+                      <a:r>
+                        <a:rPr sz="1000" b="0">
+                          <a:solidFill>
+                            <a:srgbClr val="1E293B"/>
+                          </a:solidFill>
+                        </a:rPr>
+                        <a:t>3</a:t>
+                      </a:r>
+                    </a:p>
+                  </a:txBody>
+                  <a:tcPr anchor="ctr">
+                    <a:solidFill>
+                      <a:srgbClr val="F4F8FC"/>
+                    </a:solidFill>
+                  </a:tcPr>
+                </a:tc>
+                <a:tc>
+                  <a:txBody>
+                    <a:bodyPr/>
+                    <a:lstStyle/>
+                    <a:p>
+                      <a:pPr algn="l"/>
+                      <a:r>
+                        <a:rPr sz="1000" b="0">
+                          <a:solidFill>
+                            <a:srgbClr val="1E293B"/>
+                          </a:solidFill>
+                        </a:rPr>
+                        <a:t>usrp_B210_pc5_csi_acquisition_psfch_period_test_on_two_hosts</a:t>
+                      </a:r>
+                    </a:p>
+                  </a:txBody>
+                  <a:tcPr anchor="ctr">
+                    <a:solidFill>
+                      <a:srgbClr val="F4F8FC"/>
+                    </a:solidFill>
+                  </a:tcPr>
+                </a:tc>
+              </a:tr>
+              <a:tr h="109728">
+                <a:tc>
+                  <a:txBody>
+                    <a:bodyPr/>
+                    <a:lstStyle/>
+                    <a:p>
+                      <a:pPr algn="l"/>
+                      <a:r>
+                        <a:rPr sz="1000" b="0">
+                          <a:solidFill>
+                            <a:srgbClr val="1E293B"/>
+                          </a:solidFill>
+                        </a:rPr>
+                        <a:t>slmode2_iperf3_tests</a:t>
+                      </a:r>
+                    </a:p>
+                  </a:txBody>
+                  <a:tcPr anchor="ctr">
+                    <a:solidFill>
+                      <a:srgbClr val="FFFFFF"/>
+                    </a:solidFill>
+                  </a:tcPr>
+                </a:tc>
+                <a:tc>
+                  <a:txBody>
+                    <a:bodyPr/>
+                    <a:lstStyle/>
+                    <a:p>
+                      <a:pPr algn="ctr"/>
+                      <a:r>
+                        <a:rPr sz="1000" b="0">
+                          <a:solidFill>
+                            <a:srgbClr val="1E293B"/>
+                          </a:solidFill>
+                        </a:rPr>
+                        <a:t>0</a:t>
+                      </a:r>
+                    </a:p>
+                  </a:txBody>
+                  <a:tcPr anchor="ctr">
+                    <a:solidFill>
+                      <a:srgbClr val="FFFFFF"/>
+                    </a:solidFill>
+                  </a:tcPr>
+                </a:tc>
+                <a:tc>
+                  <a:txBody>
+                    <a:bodyPr/>
+                    <a:lstStyle/>
+                    <a:p>
+                      <a:pPr algn="l"/>
+                      <a:r>
+                        <a:rPr sz="1000" b="0">
+                          <a:solidFill>
+                            <a:srgbClr val="1E293B"/>
+                          </a:solidFill>
+                        </a:rPr>
+                        <a:t>rfsim_pc5_iperf3_test_on_local_host</a:t>
+                      </a:r>
+                    </a:p>
+                  </a:txBody>
+                  <a:tcPr anchor="ctr">
+                    <a:solidFill>
+                      <a:srgbClr val="FFFFFF"/>
+                    </a:solidFill>
+                  </a:tcPr>
+                </a:tc>
+              </a:tr>
+              <a:tr h="109728">
+                <a:tc>
+                  <a:txBody>
+                    <a:bodyPr/>
+                    <a:lstStyle/>
+                    <a:p>
+                      <a:pPr algn="l"/>
+                      <a:r>
+                        <a:rPr sz="1000" b="0">
+                          <a:solidFill>
+                            <a:srgbClr val="1E293B"/>
+                          </a:solidFill>
+                        </a:rPr>
+                        <a:t/>
+                      </a:r>
+                    </a:p>
+                  </a:txBody>
+                  <a:tcPr anchor="ctr">
+                    <a:solidFill>
+                      <a:srgbClr val="F4F8FC"/>
+                    </a:solidFill>
+                  </a:tcPr>
+                </a:tc>
+                <a:tc>
+                  <a:txBody>
+                    <a:bodyPr/>
+                    <a:lstStyle/>
+                    <a:p>
+                      <a:pPr algn="ctr"/>
+                      <a:r>
+                        <a:rPr sz="1000" b="0">
+                          <a:solidFill>
+                            <a:srgbClr val="1E293B"/>
+                          </a:solidFill>
+                        </a:rPr>
                         <a:t>1</a:t>
                       </a:r>
                     </a:p>
                   </a:txBody>
                   <a:tcPr anchor="ctr">
                     <a:solidFill>
+                      <a:srgbClr val="F4F8FC"/>
+                    </a:solidFill>
+                  </a:tcPr>
+                </a:tc>
+                <a:tc>
+                  <a:txBody>
+                    <a:bodyPr/>
+                    <a:lstStyle/>
+                    <a:p>
+                      <a:pPr algn="l"/>
+                      <a:r>
+                        <a:rPr sz="1000" b="0">
+                          <a:solidFill>
+                            <a:srgbClr val="1E293B"/>
+                          </a:solidFill>
+                        </a:rPr>
+                        <a:t>vrtsim_pc5_iperf3_test_on_local_host</a:t>
+                      </a:r>
+                    </a:p>
+                  </a:txBody>
+                  <a:tcPr anchor="ctr">
+                    <a:solidFill>
+                      <a:srgbClr val="F4F8FC"/>
+                    </a:solidFill>
+                  </a:tcPr>
+                </a:tc>
+              </a:tr>
+              <a:tr h="109728">
+                <a:tc>
+                  <a:txBody>
+                    <a:bodyPr/>
+                    <a:lstStyle/>
+                    <a:p>
+                      <a:pPr algn="l"/>
+                      <a:r>
+                        <a:rPr sz="1000" b="0">
+                          <a:solidFill>
+                            <a:srgbClr val="1E293B"/>
+                          </a:solidFill>
+                        </a:rPr>
+                        <a:t/>
+                      </a:r>
+                    </a:p>
+                  </a:txBody>
+                  <a:tcPr anchor="ctr">
+                    <a:solidFill>
                       <a:srgbClr val="FFFFFF"/>
                     </a:solidFill>
                   </a:tcPr>
@@ -11788,6 +12446,28 @@
                     <a:bodyPr/>
                     <a:lstStyle/>
                     <a:p>
+                      <a:pPr algn="ctr"/>
+                      <a:r>
+                        <a:rPr sz="1000" b="0">
+                          <a:solidFill>
+                            <a:srgbClr val="1E293B"/>
+                          </a:solidFill>
+                        </a:rPr>
+                        <a:t>2</a:t>
+                      </a:r>
+                    </a:p>
+                  </a:txBody>
+                  <a:tcPr anchor="ctr">
+                    <a:solidFill>
+                      <a:srgbClr val="FFFFFF"/>
+                    </a:solidFill>
+                  </a:tcPr>
+                </a:tc>
+                <a:tc>
+                  <a:txBody>
+                    <a:bodyPr/>
+                    <a:lstStyle/>
+                    <a:p>
                       <a:pPr algn="l"/>
                       <a:r>
                         <a:rPr sz="1000" b="0">
@@ -11795,7 +12475,7 @@
                             <a:srgbClr val="1E293B"/>
                           </a:solidFill>
                         </a:rPr>
-                        <a:t>rfsim_pc5_ping_test_on_two_hosts</a:t>
+                        <a:t>rfsim_pc5_iperf3_test_on_two_hosts</a:t>
                       </a:r>
                     </a:p>
                   </a:txBody>
@@ -11806,7 +12486,7 @@
                   </a:tcPr>
                 </a:tc>
               </a:tr>
-              <a:tr h="109727">
+              <a:tr h="109728">
                 <a:tc>
                   <a:txBody>
                     <a:bodyPr/>
@@ -11841,12 +12521,262 @@
                             <a:srgbClr val="1E293B"/>
                           </a:solidFill>
                         </a:rPr>
+                        <a:t>3</a:t>
+                      </a:r>
+                    </a:p>
+                  </a:txBody>
+                  <a:tcPr anchor="ctr">
+                    <a:solidFill>
+                      <a:srgbClr val="F4F8FC"/>
+                    </a:solidFill>
+                  </a:tcPr>
+                </a:tc>
+                <a:tc>
+                  <a:txBody>
+                    <a:bodyPr/>
+                    <a:lstStyle/>
+                    <a:p>
+                      <a:pPr algn="l"/>
+                      <a:r>
+                        <a:rPr sz="1000" b="0">
+                          <a:solidFill>
+                            <a:srgbClr val="1E293B"/>
+                          </a:solidFill>
+                        </a:rPr>
+                        <a:t>usrp_B210_pc5_iperf3_test_on_two_hosts</a:t>
+                      </a:r>
+                    </a:p>
+                  </a:txBody>
+                  <a:tcPr anchor="ctr">
+                    <a:solidFill>
+                      <a:srgbClr val="F4F8FC"/>
+                    </a:solidFill>
+                  </a:tcPr>
+                </a:tc>
+              </a:tr>
+              <a:tr h="109728">
+                <a:tc>
+                  <a:txBody>
+                    <a:bodyPr/>
+                    <a:lstStyle/>
+                    <a:p>
+                      <a:pPr algn="l"/>
+                      <a:r>
+                        <a:rPr sz="1000" b="0">
+                          <a:solidFill>
+                            <a:srgbClr val="1E293B"/>
+                          </a:solidFill>
+                        </a:rPr>
+                        <a:t>slmode1_basic_tests</a:t>
+                      </a:r>
+                    </a:p>
+                  </a:txBody>
+                  <a:tcPr anchor="ctr">
+                    <a:solidFill>
+                      <a:srgbClr val="FFFFFF"/>
+                    </a:solidFill>
+                  </a:tcPr>
+                </a:tc>
+                <a:tc>
+                  <a:txBody>
+                    <a:bodyPr/>
+                    <a:lstStyle/>
+                    <a:p>
+                      <a:pPr algn="ctr"/>
+                      <a:r>
+                        <a:rPr sz="1000" b="0">
+                          <a:solidFill>
+                            <a:srgbClr val="1E293B"/>
+                          </a:solidFill>
+                        </a:rPr>
+                        <a:t>0</a:t>
+                      </a:r>
+                    </a:p>
+                  </a:txBody>
+                  <a:tcPr anchor="ctr">
+                    <a:solidFill>
+                      <a:srgbClr val="FFFFFF"/>
+                    </a:solidFill>
+                  </a:tcPr>
+                </a:tc>
+                <a:tc>
+                  <a:txBody>
+                    <a:bodyPr/>
+                    <a:lstStyle/>
+                    <a:p>
+                      <a:pPr algn="l"/>
+                      <a:r>
+                        <a:rPr sz="1000" b="0">
+                          <a:solidFill>
+                            <a:srgbClr val="1E293B"/>
+                          </a:solidFill>
+                        </a:rPr>
+                        <a:t>rfsim_slmode1_srap_ping_test_on_local_host</a:t>
+                      </a:r>
+                    </a:p>
+                  </a:txBody>
+                  <a:tcPr anchor="ctr">
+                    <a:solidFill>
+                      <a:srgbClr val="FFFFFF"/>
+                    </a:solidFill>
+                  </a:tcPr>
+                </a:tc>
+              </a:tr>
+              <a:tr h="109728">
+                <a:tc>
+                  <a:txBody>
+                    <a:bodyPr/>
+                    <a:lstStyle/>
+                    <a:p>
+                      <a:pPr algn="l"/>
+                      <a:r>
+                        <a:rPr sz="1000" b="0">
+                          <a:solidFill>
+                            <a:srgbClr val="1E293B"/>
+                          </a:solidFill>
+                        </a:rPr>
+                        <a:t/>
+                      </a:r>
+                    </a:p>
+                  </a:txBody>
+                  <a:tcPr anchor="ctr">
+                    <a:solidFill>
+                      <a:srgbClr val="F4F8FC"/>
+                    </a:solidFill>
+                  </a:tcPr>
+                </a:tc>
+                <a:tc>
+                  <a:txBody>
+                    <a:bodyPr/>
+                    <a:lstStyle/>
+                    <a:p>
+                      <a:pPr algn="ctr"/>
+                      <a:r>
+                        <a:rPr sz="1000" b="0">
+                          <a:solidFill>
+                            <a:srgbClr val="1E293B"/>
+                          </a:solidFill>
+                        </a:rPr>
+                        <a:t>1</a:t>
+                      </a:r>
+                    </a:p>
+                  </a:txBody>
+                  <a:tcPr anchor="ctr">
+                    <a:solidFill>
+                      <a:srgbClr val="F4F8FC"/>
+                    </a:solidFill>
+                  </a:tcPr>
+                </a:tc>
+                <a:tc>
+                  <a:txBody>
+                    <a:bodyPr/>
+                    <a:lstStyle/>
+                    <a:p>
+                      <a:pPr algn="l"/>
+                      <a:r>
+                        <a:rPr sz="1000" b="0">
+                          <a:solidFill>
+                            <a:srgbClr val="1E293B"/>
+                          </a:solidFill>
+                        </a:rPr>
+                        <a:t>vrtsim_slmode1_srap_ping_test_on_local_host</a:t>
+                      </a:r>
+                    </a:p>
+                  </a:txBody>
+                  <a:tcPr anchor="ctr">
+                    <a:solidFill>
+                      <a:srgbClr val="F4F8FC"/>
+                    </a:solidFill>
+                  </a:tcPr>
+                </a:tc>
+              </a:tr>
+              <a:tr h="109728">
+                <a:tc>
+                  <a:txBody>
+                    <a:bodyPr/>
+                    <a:lstStyle/>
+                    <a:p>
+                      <a:pPr algn="l"/>
+                      <a:r>
+                        <a:rPr sz="1000" b="0">
+                          <a:solidFill>
+                            <a:srgbClr val="1E293B"/>
+                          </a:solidFill>
+                        </a:rPr>
+                        <a:t/>
+                      </a:r>
+                    </a:p>
+                  </a:txBody>
+                  <a:tcPr anchor="ctr">
+                    <a:solidFill>
+                      <a:srgbClr val="FFFFFF"/>
+                    </a:solidFill>
+                  </a:tcPr>
+                </a:tc>
+                <a:tc>
+                  <a:txBody>
+                    <a:bodyPr/>
+                    <a:lstStyle/>
+                    <a:p>
+                      <a:pPr algn="ctr"/>
+                      <a:r>
+                        <a:rPr sz="1000" b="0">
+                          <a:solidFill>
+                            <a:srgbClr val="1E293B"/>
+                          </a:solidFill>
+                        </a:rPr>
                         <a:t>2</a:t>
                       </a:r>
                     </a:p>
                   </a:txBody>
                   <a:tcPr anchor="ctr">
                     <a:solidFill>
+                      <a:srgbClr val="FFFFFF"/>
+                    </a:solidFill>
+                  </a:tcPr>
+                </a:tc>
+                <a:tc>
+                  <a:txBody>
+                    <a:bodyPr/>
+                    <a:lstStyle/>
+                    <a:p>
+                      <a:pPr algn="l"/>
+                      <a:r>
+                        <a:rPr sz="1000" b="0">
+                          <a:solidFill>
+                            <a:srgbClr val="1E293B"/>
+                          </a:solidFill>
+                        </a:rPr>
+                        <a:t>rfsim_slmode1_srap_ping_test_on_three_hosts</a:t>
+                      </a:r>
+                    </a:p>
+                  </a:txBody>
+                  <a:tcPr anchor="ctr">
+                    <a:solidFill>
+                      <a:srgbClr val="FFFFFF"/>
+                    </a:solidFill>
+                  </a:tcPr>
+                </a:tc>
+              </a:tr>
+              <a:tr h="109728">
+                <a:tc>
+                  <a:txBody>
+                    <a:bodyPr/>
+                    <a:lstStyle/>
+                    <a:p>
+                      <a:pPr algn="l"/>
+                      <a:r>
+                        <a:rPr sz="1000" b="0">
+                          <a:solidFill>
+                            <a:srgbClr val="1E293B"/>
+                          </a:solidFill>
+                        </a:rPr>
+                        <a:t/>
+                      </a:r>
+                    </a:p>
+                  </a:txBody>
+                  <a:tcPr anchor="ctr">
+                    <a:solidFill>
                       <a:srgbClr val="F4F8FC"/>
                     </a:solidFill>
                   </a:tcPr>
@@ -11856,6 +12786,28 @@
                     <a:bodyPr/>
                     <a:lstStyle/>
                     <a:p>
+                      <a:pPr algn="ctr"/>
+                      <a:r>
+                        <a:rPr sz="1000" b="0">
+                          <a:solidFill>
+                            <a:srgbClr val="1E293B"/>
+                          </a:solidFill>
+                        </a:rPr>
+                        <a:t>3</a:t>
+                      </a:r>
+                    </a:p>
+                  </a:txBody>
+                  <a:tcPr anchor="ctr">
+                    <a:solidFill>
+                      <a:srgbClr val="F4F8FC"/>
+                    </a:solidFill>
+                  </a:tcPr>
+                </a:tc>
+                <a:tc>
+                  <a:txBody>
+                    <a:bodyPr/>
+                    <a:lstStyle/>
+                    <a:p>
                       <a:pPr algn="l"/>
                       <a:r>
                         <a:rPr sz="1000" b="0">
@@ -11863,7 +12815,7 @@
                             <a:srgbClr val="1E293B"/>
                           </a:solidFill>
                         </a:rPr>
-                        <a:t>usrp_B210_pc5_ping_test_on_two_hosts</a:t>
+                        <a:t>usrp_B210_slmode1_srap_ping_test_on_three_hosts</a:t>
                       </a:r>
                     </a:p>
                   </a:txBody>
@@ -11874,7 +12826,7 @@
                   </a:tcPr>
                 </a:tc>
               </a:tr>
-              <a:tr h="109727">
+              <a:tr h="109728">
                 <a:tc>
                   <a:txBody>
                     <a:bodyPr/>
@@ -11887,7 +12839,7 @@
                             <a:srgbClr val="1E293B"/>
                           </a:solidFill>
                         </a:rPr>
-                        <a:t>slmode2_csi_psfch_tests</a:t>
+                        <a:t>slmode1_iperf3_tests</a:t>
                       </a:r>
                     </a:p>
                   </a:txBody>
@@ -11931,7 +12883,7 @@
                             <a:srgbClr val="1E293B"/>
                           </a:solidFill>
                         </a:rPr>
-                        <a:t>rfsim_pc5_csi_acquisition_psfch_period_test_on_local_host</a:t>
+                        <a:t>rfsim_slmode1_srap_iperf3_test_on_local_host</a:t>
                       </a:r>
                     </a:p>
                   </a:txBody>
@@ -11942,7 +12894,7 @@
                   </a:tcPr>
                 </a:tc>
               </a:tr>
-              <a:tr h="109727">
+              <a:tr h="109728">
                 <a:tc>
                   <a:txBody>
                     <a:bodyPr/>
@@ -11999,7 +12951,7 @@
                             <a:srgbClr val="1E293B"/>
                           </a:solidFill>
                         </a:rPr>
-                        <a:t>rfsim_pc5_csi_acquisition_psfch_period_test_on_two_hosts</a:t>
+                        <a:t>vrtsim_slmode1_srap_iperf3_test_on_local_host</a:t>
                       </a:r>
                     </a:p>
                   </a:txBody>
@@ -12010,7 +12962,7 @@
                   </a:tcPr>
                 </a:tc>
               </a:tr>
-              <a:tr h="109727">
+              <a:tr h="109728">
                 <a:tc>
                   <a:txBody>
                     <a:bodyPr/>
@@ -12067,7 +13019,7 @@
                             <a:srgbClr val="1E293B"/>
                           </a:solidFill>
                         </a:rPr>
-                        <a:t>usrp_B210_pc5_csi_acquisition_psfch_period_test_on_two_hosts</a:t>
+                        <a:t>rfsim_slmode1_srap_iperf3_test_on_three_hosts</a:t>
                       </a:r>
                     </a:p>
                   </a:txBody>
@@ -12078,7 +13030,7 @@
                   </a:tcPr>
                 </a:tc>
               </a:tr>
-              <a:tr h="109727">
+              <a:tr h="109728">
                 <a:tc>
                   <a:txBody>
                     <a:bodyPr/>
@@ -12091,7 +13043,7 @@
                             <a:srgbClr val="1E293B"/>
                           </a:solidFill>
                         </a:rPr>
-                        <a:t>slmode2_iperf3_tests</a:t>
+                        <a:t/>
                       </a:r>
                     </a:p>
                   </a:txBody>
@@ -12113,12 +13065,126 @@
                             <a:srgbClr val="1E293B"/>
                           </a:solidFill>
                         </a:rPr>
+                        <a:t>3</a:t>
+                      </a:r>
+                    </a:p>
+                  </a:txBody>
+                  <a:tcPr anchor="ctr">
+                    <a:solidFill>
+                      <a:srgbClr val="F4F8FC"/>
+                    </a:solidFill>
+                  </a:tcPr>
+                </a:tc>
+                <a:tc>
+                  <a:txBody>
+                    <a:bodyPr/>
+                    <a:lstStyle/>
+                    <a:p>
+                      <a:pPr algn="l"/>
+                      <a:r>
+                        <a:rPr sz="1000" b="0">
+                          <a:solidFill>
+                            <a:srgbClr val="1E293B"/>
+                          </a:solidFill>
+                        </a:rPr>
+                        <a:t>usrp_B210_slmode1_srap_iperf3_test_on_three_hosts</a:t>
+                      </a:r>
+                    </a:p>
+                  </a:txBody>
+                  <a:tcPr anchor="ctr">
+                    <a:solidFill>
+                      <a:srgbClr val="F4F8FC"/>
+                    </a:solidFill>
+                  </a:tcPr>
+                </a:tc>
+              </a:tr>
+              <a:tr h="109728">
+                <a:tc>
+                  <a:txBody>
+                    <a:bodyPr/>
+                    <a:lstStyle/>
+                    <a:p>
+                      <a:pPr algn="l"/>
+                      <a:r>
+                        <a:rPr sz="1000" b="0">
+                          <a:solidFill>
+                            <a:srgbClr val="1E293B"/>
+                          </a:solidFill>
+                        </a:rPr>
+                        <a:t>slmode1_csi_psfch_tests</a:t>
+                      </a:r>
+                    </a:p>
+                  </a:txBody>
+                  <a:tcPr anchor="ctr">
+                    <a:solidFill>
+                      <a:srgbClr val="FFFFFF"/>
+                    </a:solidFill>
+                  </a:tcPr>
+                </a:tc>
+                <a:tc>
+                  <a:txBody>
+                    <a:bodyPr/>
+                    <a:lstStyle/>
+                    <a:p>
+                      <a:pPr algn="ctr"/>
+                      <a:r>
+                        <a:rPr sz="1000" b="0">
+                          <a:solidFill>
+                            <a:srgbClr val="1E293B"/>
+                          </a:solidFill>
+                        </a:rPr>
                         <a:t>0</a:t>
                       </a:r>
                     </a:p>
                   </a:txBody>
                   <a:tcPr anchor="ctr">
                     <a:solidFill>
+                      <a:srgbClr val="FFFFFF"/>
+                    </a:solidFill>
+                  </a:tcPr>
+                </a:tc>
+                <a:tc>
+                  <a:txBody>
+                    <a:bodyPr/>
+                    <a:lstStyle/>
+                    <a:p>
+                      <a:pPr algn="l"/>
+                      <a:r>
+                        <a:rPr sz="1000" b="0">
+                          <a:solidFill>
+                            <a:srgbClr val="1E293B"/>
+                          </a:solidFill>
+                        </a:rPr>
+                        <a:t>rfsim_slmode1_srap_csi_acquisition_psfch_period_test_on_local_host</a:t>
+                      </a:r>
+                    </a:p>
+                  </a:txBody>
+                  <a:tcPr anchor="ctr">
+                    <a:solidFill>
+                      <a:srgbClr val="FFFFFF"/>
+                    </a:solidFill>
+                  </a:tcPr>
+                </a:tc>
+              </a:tr>
+              <a:tr h="109728">
+                <a:tc>
+                  <a:txBody>
+                    <a:bodyPr/>
+                    <a:lstStyle/>
+                    <a:p>
+                      <a:pPr algn="l"/>
+                      <a:r>
+                        <a:rPr sz="1000" b="0">
+                          <a:solidFill>
+                            <a:srgbClr val="1E293B"/>
+                          </a:solidFill>
+                        </a:rPr>
+                        <a:t/>
+                      </a:r>
+                    </a:p>
+                  </a:txBody>
+                  <a:tcPr anchor="ctr">
+                    <a:solidFill>
                       <a:srgbClr val="F4F8FC"/>
                     </a:solidFill>
                   </a:tcPr>
@@ -12128,6 +13194,28 @@
                     <a:bodyPr/>
                     <a:lstStyle/>
                     <a:p>
+                      <a:pPr algn="ctr"/>
+                      <a:r>
+                        <a:rPr sz="1000" b="0">
+                          <a:solidFill>
+                            <a:srgbClr val="1E293B"/>
+                          </a:solidFill>
+                        </a:rPr>
+                        <a:t>1</a:t>
+                      </a:r>
+                    </a:p>
+                  </a:txBody>
+                  <a:tcPr anchor="ctr">
+                    <a:solidFill>
+                      <a:srgbClr val="F4F8FC"/>
+                    </a:solidFill>
+                  </a:tcPr>
+                </a:tc>
+                <a:tc>
+                  <a:txBody>
+                    <a:bodyPr/>
+                    <a:lstStyle/>
+                    <a:p>
                       <a:pPr algn="l"/>
                       <a:r>
                         <a:rPr sz="1000" b="0">
@@ -12135,7 +13223,7 @@
                             <a:srgbClr val="1E293B"/>
                           </a:solidFill>
                         </a:rPr>
-                        <a:t>rfsim_pc5_iperf3_test_on_local_host</a:t>
+                        <a:t>vrtsim_slmode1_srap_csi_acquisition_psfch_period_test_on_local_host</a:t>
                       </a:r>
                     </a:p>
                   </a:txBody>
@@ -12146,7 +13234,7 @@
                   </a:tcPr>
                 </a:tc>
               </a:tr>
-              <a:tr h="109727">
+              <a:tr h="109728">
                 <a:tc>
                   <a:txBody>
                     <a:bodyPr/>
@@ -12181,7 +13269,7 @@
                             <a:srgbClr val="1E293B"/>
                           </a:solidFill>
                         </a:rPr>
-                        <a:t>1</a:t>
+                        <a:t>2</a:t>
                       </a:r>
                     </a:p>
                   </a:txBody>
@@ -12203,7 +13291,7 @@
                             <a:srgbClr val="1E293B"/>
                           </a:solidFill>
                         </a:rPr>
-                        <a:t>rfsim_pc5_iperf3_test_on_two_hosts</a:t>
+                        <a:t>rfsim_slmode1_srap_csi_acquisition_psfch_period_test_on_three_hosts</a:t>
                       </a:r>
                     </a:p>
                   </a:txBody>
@@ -12214,7 +13302,7 @@
                   </a:tcPr>
                 </a:tc>
               </a:tr>
-              <a:tr h="109727">
+              <a:tr h="109728">
                 <a:tc>
                   <a:txBody>
                     <a:bodyPr/>
@@ -12249,7 +13337,7 @@
                             <a:srgbClr val="1E293B"/>
                           </a:solidFill>
                         </a:rPr>
-                        <a:t>2</a:t>
+                        <a:t>3</a:t>
                       </a:r>
                     </a:p>
                   </a:txBody>
@@ -12271,625 +13359,13 @@
                             <a:srgbClr val="1E293B"/>
                           </a:solidFill>
                         </a:rPr>
-                        <a:t>usrp_B210_pc5_iperf3_test_on_two_hosts</a:t>
+                        <a:t>usrp_B210_slmode1_srap_csi_acquisition_psfch_period_test_on_three_hosts</a:t>
                       </a:r>
                     </a:p>
                   </a:txBody>
                   <a:tcPr anchor="ctr">
                     <a:solidFill>
                       <a:srgbClr val="F4F8FC"/>
-                    </a:solidFill>
-                  </a:tcPr>
-                </a:tc>
-              </a:tr>
-              <a:tr h="109727">
-                <a:tc>
-                  <a:txBody>
-                    <a:bodyPr/>
-                    <a:lstStyle/>
-                    <a:p>
-                      <a:pPr algn="l"/>
-                      <a:r>
-                        <a:rPr sz="1000" b="0">
-                          <a:solidFill>
-                            <a:srgbClr val="1E293B"/>
-                          </a:solidFill>
-                        </a:rPr>
-                        <a:t>slmode1_basic_tests</a:t>
-                      </a:r>
-                    </a:p>
-                  </a:txBody>
-                  <a:tcPr anchor="ctr">
-                    <a:solidFill>
-                      <a:srgbClr val="FFFFFF"/>
-                    </a:solidFill>
-                  </a:tcPr>
-                </a:tc>
-                <a:tc>
-                  <a:txBody>
-                    <a:bodyPr/>
-                    <a:lstStyle/>
-                    <a:p>
-                      <a:pPr algn="ctr"/>
-                      <a:r>
-                        <a:rPr sz="1000" b="0">
-                          <a:solidFill>
-                            <a:srgbClr val="1E293B"/>
-                          </a:solidFill>
-                        </a:rPr>
-                        <a:t>0</a:t>
-                      </a:r>
-                    </a:p>
-                  </a:txBody>
-                  <a:tcPr anchor="ctr">
-                    <a:solidFill>
-                      <a:srgbClr val="FFFFFF"/>
-                    </a:solidFill>
-                  </a:tcPr>
-                </a:tc>
-                <a:tc>
-                  <a:txBody>
-                    <a:bodyPr/>
-                    <a:lstStyle/>
-                    <a:p>
-                      <a:pPr algn="l"/>
-                      <a:r>
-                        <a:rPr sz="1000" b="0">
-                          <a:solidFill>
-                            <a:srgbClr val="1E293B"/>
-                          </a:solidFill>
-                        </a:rPr>
-                        <a:t>rfsim_slmode1_srap_ping_test_on_local_host</a:t>
-                      </a:r>
-                    </a:p>
-                  </a:txBody>
-                  <a:tcPr anchor="ctr">
-                    <a:solidFill>
-                      <a:srgbClr val="FFFFFF"/>
-                    </a:solidFill>
-                  </a:tcPr>
-                </a:tc>
-              </a:tr>
-              <a:tr h="109727">
-                <a:tc>
-                  <a:txBody>
-                    <a:bodyPr/>
-                    <a:lstStyle/>
-                    <a:p>
-                      <a:pPr algn="l"/>
-                      <a:r>
-                        <a:rPr sz="1000" b="0">
-                          <a:solidFill>
-                            <a:srgbClr val="1E293B"/>
-                          </a:solidFill>
-                        </a:rPr>
-                        <a:t/>
-                      </a:r>
-                    </a:p>
-                  </a:txBody>
-                  <a:tcPr anchor="ctr">
-                    <a:solidFill>
-                      <a:srgbClr val="F4F8FC"/>
-                    </a:solidFill>
-                  </a:tcPr>
-                </a:tc>
-                <a:tc>
-                  <a:txBody>
-                    <a:bodyPr/>
-                    <a:lstStyle/>
-                    <a:p>
-                      <a:pPr algn="ctr"/>
-                      <a:r>
-                        <a:rPr sz="1000" b="0">
-                          <a:solidFill>
-                            <a:srgbClr val="1E293B"/>
-                          </a:solidFill>
-                        </a:rPr>
-                        <a:t>1</a:t>
-                      </a:r>
-                    </a:p>
-                  </a:txBody>
-                  <a:tcPr anchor="ctr">
-                    <a:solidFill>
-                      <a:srgbClr val="F4F8FC"/>
-                    </a:solidFill>
-                  </a:tcPr>
-                </a:tc>
-                <a:tc>
-                  <a:txBody>
-                    <a:bodyPr/>
-                    <a:lstStyle/>
-                    <a:p>
-                      <a:pPr algn="l"/>
-                      <a:r>
-                        <a:rPr sz="1000" b="0">
-                          <a:solidFill>
-                            <a:srgbClr val="1E293B"/>
-                          </a:solidFill>
-                        </a:rPr>
-                        <a:t>rfsim_slmode1_srap_ping_test_on_three_hosts</a:t>
-                      </a:r>
-                    </a:p>
-                  </a:txBody>
-                  <a:tcPr anchor="ctr">
-                    <a:solidFill>
-                      <a:srgbClr val="F4F8FC"/>
-                    </a:solidFill>
-                  </a:tcPr>
-                </a:tc>
-              </a:tr>
-              <a:tr h="109727">
-                <a:tc>
-                  <a:txBody>
-                    <a:bodyPr/>
-                    <a:lstStyle/>
-                    <a:p>
-                      <a:pPr algn="l"/>
-                      <a:r>
-                        <a:rPr sz="1000" b="0">
-                          <a:solidFill>
-                            <a:srgbClr val="1E293B"/>
-                          </a:solidFill>
-                        </a:rPr>
-                        <a:t/>
-                      </a:r>
-                    </a:p>
-                  </a:txBody>
-                  <a:tcPr anchor="ctr">
-                    <a:solidFill>
-                      <a:srgbClr val="FFFFFF"/>
-                    </a:solidFill>
-                  </a:tcPr>
-                </a:tc>
-                <a:tc>
-                  <a:txBody>
-                    <a:bodyPr/>
-                    <a:lstStyle/>
-                    <a:p>
-                      <a:pPr algn="ctr"/>
-                      <a:r>
-                        <a:rPr sz="1000" b="0">
-                          <a:solidFill>
-                            <a:srgbClr val="1E293B"/>
-                          </a:solidFill>
-                        </a:rPr>
-                        <a:t>2</a:t>
-                      </a:r>
-                    </a:p>
-                  </a:txBody>
-                  <a:tcPr anchor="ctr">
-                    <a:solidFill>
-                      <a:srgbClr val="FFFFFF"/>
-                    </a:solidFill>
-                  </a:tcPr>
-                </a:tc>
-                <a:tc>
-                  <a:txBody>
-                    <a:bodyPr/>
-                    <a:lstStyle/>
-                    <a:p>
-                      <a:pPr algn="l"/>
-                      <a:r>
-                        <a:rPr sz="1000" b="0">
-                          <a:solidFill>
-                            <a:srgbClr val="1E293B"/>
-                          </a:solidFill>
-                        </a:rPr>
-                        <a:t>usrp_B210_slmode1_srap_ping_test_on_three_hosts</a:t>
-                      </a:r>
-                    </a:p>
-                  </a:txBody>
-                  <a:tcPr anchor="ctr">
-                    <a:solidFill>
-                      <a:srgbClr val="FFFFFF"/>
-                    </a:solidFill>
-                  </a:tcPr>
-                </a:tc>
-              </a:tr>
-              <a:tr h="109727">
-                <a:tc>
-                  <a:txBody>
-                    <a:bodyPr/>
-                    <a:lstStyle/>
-                    <a:p>
-                      <a:pPr algn="l"/>
-                      <a:r>
-                        <a:rPr sz="1000" b="0">
-                          <a:solidFill>
-                            <a:srgbClr val="1E293B"/>
-                          </a:solidFill>
-                        </a:rPr>
-                        <a:t>slmode1_iperf3_tests</a:t>
-                      </a:r>
-                    </a:p>
-                  </a:txBody>
-                  <a:tcPr anchor="ctr">
-                    <a:solidFill>
-                      <a:srgbClr val="F4F8FC"/>
-                    </a:solidFill>
-                  </a:tcPr>
-                </a:tc>
-                <a:tc>
-                  <a:txBody>
-                    <a:bodyPr/>
-                    <a:lstStyle/>
-                    <a:p>
-                      <a:pPr algn="ctr"/>
-                      <a:r>
-                        <a:rPr sz="1000" b="0">
-                          <a:solidFill>
-                            <a:srgbClr val="1E293B"/>
-                          </a:solidFill>
-                        </a:rPr>
-                        <a:t>0</a:t>
-                      </a:r>
-                    </a:p>
-                  </a:txBody>
-                  <a:tcPr anchor="ctr">
-                    <a:solidFill>
-                      <a:srgbClr val="F4F8FC"/>
-                    </a:solidFill>
-                  </a:tcPr>
-                </a:tc>
-                <a:tc>
-                  <a:txBody>
-                    <a:bodyPr/>
-                    <a:lstStyle/>
-                    <a:p>
-                      <a:pPr algn="l"/>
-                      <a:r>
-                        <a:rPr sz="1000" b="0">
-                          <a:solidFill>
-                            <a:srgbClr val="1E293B"/>
-                          </a:solidFill>
-                        </a:rPr>
-                        <a:t>rfsim_slmode1_srap_iperf3_test_on_local_host</a:t>
-                      </a:r>
-                    </a:p>
-                  </a:txBody>
-                  <a:tcPr anchor="ctr">
-                    <a:solidFill>
-                      <a:srgbClr val="F4F8FC"/>
-                    </a:solidFill>
-                  </a:tcPr>
-                </a:tc>
-              </a:tr>
-              <a:tr h="109727">
-                <a:tc>
-                  <a:txBody>
-                    <a:bodyPr/>
-                    <a:lstStyle/>
-                    <a:p>
-                      <a:pPr algn="l"/>
-                      <a:r>
-                        <a:rPr sz="1000" b="0">
-                          <a:solidFill>
-                            <a:srgbClr val="1E293B"/>
-                          </a:solidFill>
-                        </a:rPr>
-                        <a:t/>
-                      </a:r>
-                    </a:p>
-                  </a:txBody>
-                  <a:tcPr anchor="ctr">
-                    <a:solidFill>
-                      <a:srgbClr val="FFFFFF"/>
-                    </a:solidFill>
-                  </a:tcPr>
-                </a:tc>
-                <a:tc>
-                  <a:txBody>
-                    <a:bodyPr/>
-                    <a:lstStyle/>
-                    <a:p>
-                      <a:pPr algn="ctr"/>
-                      <a:r>
-                        <a:rPr sz="1000" b="0">
-                          <a:solidFill>
-                            <a:srgbClr val="1E293B"/>
-                          </a:solidFill>
-                        </a:rPr>
-                        <a:t>1</a:t>
-                      </a:r>
-                    </a:p>
-                  </a:txBody>
-                  <a:tcPr anchor="ctr">
-                    <a:solidFill>
-                      <a:srgbClr val="FFFFFF"/>
-                    </a:solidFill>
-                  </a:tcPr>
-                </a:tc>
-                <a:tc>
-                  <a:txBody>
-                    <a:bodyPr/>
-                    <a:lstStyle/>
-                    <a:p>
-                      <a:pPr algn="l"/>
-                      <a:r>
-                        <a:rPr sz="1000" b="0">
-                          <a:solidFill>
-                            <a:srgbClr val="1E293B"/>
-                          </a:solidFill>
-                        </a:rPr>
-                        <a:t>rfsim_slmode1_srap_iperf3_test_on_three_hosts</a:t>
-                      </a:r>
-                    </a:p>
-                  </a:txBody>
-                  <a:tcPr anchor="ctr">
-                    <a:solidFill>
-                      <a:srgbClr val="FFFFFF"/>
-                    </a:solidFill>
-                  </a:tcPr>
-                </a:tc>
-              </a:tr>
-              <a:tr h="109727">
-                <a:tc>
-                  <a:txBody>
-                    <a:bodyPr/>
-                    <a:lstStyle/>
-                    <a:p>
-                      <a:pPr algn="l"/>
-                      <a:r>
-                        <a:rPr sz="1000" b="0">
-                          <a:solidFill>
-                            <a:srgbClr val="1E293B"/>
-                          </a:solidFill>
-                        </a:rPr>
-                        <a:t/>
-                      </a:r>
-                    </a:p>
-                  </a:txBody>
-                  <a:tcPr anchor="ctr">
-                    <a:solidFill>
-                      <a:srgbClr val="F4F8FC"/>
-                    </a:solidFill>
-                  </a:tcPr>
-                </a:tc>
-                <a:tc>
-                  <a:txBody>
-                    <a:bodyPr/>
-                    <a:lstStyle/>
-                    <a:p>
-                      <a:pPr algn="ctr"/>
-                      <a:r>
-                        <a:rPr sz="1000" b="0">
-                          <a:solidFill>
-                            <a:srgbClr val="1E293B"/>
-                          </a:solidFill>
-                        </a:rPr>
-                        <a:t>2</a:t>
-                      </a:r>
-                    </a:p>
-                  </a:txBody>
-                  <a:tcPr anchor="ctr">
-                    <a:solidFill>
-                      <a:srgbClr val="F4F8FC"/>
-                    </a:solidFill>
-                  </a:tcPr>
-                </a:tc>
-                <a:tc>
-                  <a:txBody>
-                    <a:bodyPr/>
-                    <a:lstStyle/>
-                    <a:p>
-                      <a:pPr algn="l"/>
-                      <a:r>
-                        <a:rPr sz="1000" b="0">
-                          <a:solidFill>
-                            <a:srgbClr val="1E293B"/>
-                          </a:solidFill>
-                        </a:rPr>
-                        <a:t>usrp_B210_slmode1_srap_iperf3_test_on_three_hosts</a:t>
-                      </a:r>
-                    </a:p>
-                  </a:txBody>
-                  <a:tcPr anchor="ctr">
-                    <a:solidFill>
-                      <a:srgbClr val="F4F8FC"/>
-                    </a:solidFill>
-                  </a:tcPr>
-                </a:tc>
-              </a:tr>
-              <a:tr h="109727">
-                <a:tc>
-                  <a:txBody>
-                    <a:bodyPr/>
-                    <a:lstStyle/>
-                    <a:p>
-                      <a:pPr algn="l"/>
-                      <a:r>
-                        <a:rPr sz="1000" b="0">
-                          <a:solidFill>
-                            <a:srgbClr val="1E293B"/>
-                          </a:solidFill>
-                        </a:rPr>
-                        <a:t>slmode1_csi_psfch_tests</a:t>
-                      </a:r>
-                    </a:p>
-                  </a:txBody>
-                  <a:tcPr anchor="ctr">
-                    <a:solidFill>
-                      <a:srgbClr val="FFFFFF"/>
-                    </a:solidFill>
-                  </a:tcPr>
-                </a:tc>
-                <a:tc>
-                  <a:txBody>
-                    <a:bodyPr/>
-                    <a:lstStyle/>
-                    <a:p>
-                      <a:pPr algn="ctr"/>
-                      <a:r>
-                        <a:rPr sz="1000" b="0">
-                          <a:solidFill>
-                            <a:srgbClr val="1E293B"/>
-                          </a:solidFill>
-                        </a:rPr>
-                        <a:t>0</a:t>
-                      </a:r>
-                    </a:p>
-                  </a:txBody>
-                  <a:tcPr anchor="ctr">
-                    <a:solidFill>
-                      <a:srgbClr val="FFFFFF"/>
-                    </a:solidFill>
-                  </a:tcPr>
-                </a:tc>
-                <a:tc>
-                  <a:txBody>
-                    <a:bodyPr/>
-                    <a:lstStyle/>
-                    <a:p>
-                      <a:pPr algn="l"/>
-                      <a:r>
-                        <a:rPr sz="1000" b="0">
-                          <a:solidFill>
-                            <a:srgbClr val="1E293B"/>
-                          </a:solidFill>
-                        </a:rPr>
-                        <a:t>rfsim_slmode1_srap_csi_acquisition_psfch_period_test_on_local_host</a:t>
-                      </a:r>
-                    </a:p>
-                  </a:txBody>
-                  <a:tcPr anchor="ctr">
-                    <a:solidFill>
-                      <a:srgbClr val="FFFFFF"/>
-                    </a:solidFill>
-                  </a:tcPr>
-                </a:tc>
-              </a:tr>
-              <a:tr h="109727">
-                <a:tc>
-                  <a:txBody>
-                    <a:bodyPr/>
-                    <a:lstStyle/>
-                    <a:p>
-                      <a:pPr algn="l"/>
-                      <a:r>
-                        <a:rPr sz="1000" b="0">
-                          <a:solidFill>
-                            <a:srgbClr val="1E293B"/>
-                          </a:solidFill>
-                        </a:rPr>
-                        <a:t/>
-                      </a:r>
-                    </a:p>
-                  </a:txBody>
-                  <a:tcPr anchor="ctr">
-                    <a:solidFill>
-                      <a:srgbClr val="F4F8FC"/>
-                    </a:solidFill>
-                  </a:tcPr>
-                </a:tc>
-                <a:tc>
-                  <a:txBody>
-                    <a:bodyPr/>
-                    <a:lstStyle/>
-                    <a:p>
-                      <a:pPr algn="ctr"/>
-                      <a:r>
-                        <a:rPr sz="1000" b="0">
-                          <a:solidFill>
-                            <a:srgbClr val="1E293B"/>
-                          </a:solidFill>
-                        </a:rPr>
-                        <a:t>1</a:t>
-                      </a:r>
-                    </a:p>
-                  </a:txBody>
-                  <a:tcPr anchor="ctr">
-                    <a:solidFill>
-                      <a:srgbClr val="F4F8FC"/>
-                    </a:solidFill>
-                  </a:tcPr>
-                </a:tc>
-                <a:tc>
-                  <a:txBody>
-                    <a:bodyPr/>
-                    <a:lstStyle/>
-                    <a:p>
-                      <a:pPr algn="l"/>
-                      <a:r>
-                        <a:rPr sz="1000" b="0">
-                          <a:solidFill>
-                            <a:srgbClr val="1E293B"/>
-                          </a:solidFill>
-                        </a:rPr>
-                        <a:t>rfsim_slmode1_srap_csi_acquisition_psfch_period_test_on_three_hosts</a:t>
-                      </a:r>
-                    </a:p>
-                  </a:txBody>
-                  <a:tcPr anchor="ctr">
-                    <a:solidFill>
-                      <a:srgbClr val="F4F8FC"/>
-                    </a:solidFill>
-                  </a:tcPr>
-                </a:tc>
-              </a:tr>
-              <a:tr h="109748">
-                <a:tc>
-                  <a:txBody>
-                    <a:bodyPr/>
-                    <a:lstStyle/>
-                    <a:p>
-                      <a:pPr algn="l"/>
-                      <a:r>
-                        <a:rPr sz="1000" b="0">
-                          <a:solidFill>
-                            <a:srgbClr val="1E293B"/>
-                          </a:solidFill>
-                        </a:rPr>
-                        <a:t/>
-                      </a:r>
-                    </a:p>
-                  </a:txBody>
-                  <a:tcPr anchor="ctr">
-                    <a:solidFill>
-                      <a:srgbClr val="FFFFFF"/>
-                    </a:solidFill>
-                  </a:tcPr>
-                </a:tc>
-                <a:tc>
-                  <a:txBody>
-                    <a:bodyPr/>
-                    <a:lstStyle/>
-                    <a:p>
-                      <a:pPr algn="ctr"/>
-                      <a:r>
-                        <a:rPr sz="1000" b="0">
-                          <a:solidFill>
-                            <a:srgbClr val="1E293B"/>
-                          </a:solidFill>
-                        </a:rPr>
-                        <a:t>2</a:t>
-                      </a:r>
-                    </a:p>
-                  </a:txBody>
-                  <a:tcPr anchor="ctr">
-                    <a:solidFill>
-                      <a:srgbClr val="FFFFFF"/>
-                    </a:solidFill>
-                  </a:tcPr>
-                </a:tc>
-                <a:tc>
-                  <a:txBody>
-                    <a:bodyPr/>
-                    <a:lstStyle/>
-                    <a:p>
-                      <a:pPr algn="l"/>
-                      <a:r>
-                        <a:rPr sz="1000" b="0">
-                          <a:solidFill>
-                            <a:srgbClr val="1E293B"/>
-                          </a:solidFill>
-                        </a:rPr>
-                        <a:t>usrp_B210_slmode1_srap_csi_acquisition_psfch_period_test_on_three_hosts</a:t>
-                      </a:r>
-                    </a:p>
-                  </a:txBody>
-                  <a:tcPr anchor="ctr">
-                    <a:solidFill>
-                      <a:srgbClr val="FFFFFF"/>
                     </a:solidFill>
                   </a:tcPr>
                 </a:tc>
@@ -13375,7 +13851,7 @@
         </p:nvGraphicFramePr>
         <p:xfrm>
           <a:off x="548640" y="777240"/>
-          <a:ext cx="10972800" cy="3200400"/>
+          <a:ext cx="10972800" cy="3621024"/>
         </p:xfrm>
         <a:graphic>
           <a:graphicData uri="http://schemas.openxmlformats.org/drawingml/2006/table">
@@ -13389,7 +13865,7 @@
                 <a:gridCol w="914400"/>
                 <a:gridCol w="4572000"/>
               </a:tblGrid>
-              <a:tr h="228600">
+              <a:tr h="201168">
                 <a:tc>
                   <a:txBody>
                     <a:bodyPr/>
@@ -13479,7 +13955,7 @@
                   </a:tcPr>
                 </a:tc>
               </a:tr>
-              <a:tr h="228600">
+              <a:tr h="201168">
                 <a:tc>
                   <a:txBody>
                     <a:bodyPr/>
@@ -13569,7 +14045,7 @@
                   </a:tcPr>
                 </a:tc>
               </a:tr>
-              <a:tr h="228600">
+              <a:tr h="201168">
                 <a:tc>
                   <a:txBody>
                     <a:bodyPr/>
@@ -13659,7 +14135,7 @@
                   </a:tcPr>
                 </a:tc>
               </a:tr>
-              <a:tr h="228600">
+              <a:tr h="201168">
                 <a:tc>
                   <a:txBody>
                     <a:bodyPr/>
@@ -13749,7 +14225,7 @@
                   </a:tcPr>
                 </a:tc>
               </a:tr>
-              <a:tr h="228600">
+              <a:tr h="201168">
                 <a:tc>
                   <a:txBody>
                     <a:bodyPr/>
@@ -13839,7 +14315,7 @@
                   </a:tcPr>
                 </a:tc>
               </a:tr>
-              <a:tr h="228600">
+              <a:tr h="201168">
                 <a:tc>
                   <a:txBody>
                     <a:bodyPr/>
@@ -13929,7 +14405,7 @@
                   </a:tcPr>
                 </a:tc>
               </a:tr>
-              <a:tr h="228600">
+              <a:tr h="201168">
                 <a:tc>
                   <a:txBody>
                     <a:bodyPr/>
@@ -14019,7 +14495,7 @@
                   </a:tcPr>
                 </a:tc>
               </a:tr>
-              <a:tr h="228600">
+              <a:tr h="201168">
                 <a:tc>
                   <a:txBody>
                     <a:bodyPr/>
@@ -14109,7 +14585,7 @@
                   </a:tcPr>
                 </a:tc>
               </a:tr>
-              <a:tr h="228600">
+              <a:tr h="201168">
                 <a:tc>
                   <a:txBody>
                     <a:bodyPr/>
@@ -14199,7 +14675,7 @@
                   </a:tcPr>
                 </a:tc>
               </a:tr>
-              <a:tr h="228600">
+              <a:tr h="201168">
                 <a:tc>
                   <a:txBody>
                     <a:bodyPr/>
@@ -14289,7 +14765,7 @@
                   </a:tcPr>
                 </a:tc>
               </a:tr>
-              <a:tr h="228600">
+              <a:tr h="201168">
                 <a:tc>
                   <a:txBody>
                     <a:bodyPr/>
@@ -14379,7 +14855,7 @@
                   </a:tcPr>
                 </a:tc>
               </a:tr>
-              <a:tr h="228600">
+              <a:tr h="201168">
                 <a:tc>
                   <a:txBody>
                     <a:bodyPr/>
@@ -14469,7 +14945,7 @@
                   </a:tcPr>
                 </a:tc>
               </a:tr>
-              <a:tr h="228600">
+              <a:tr h="201168">
                 <a:tc>
                   <a:txBody>
                     <a:bodyPr/>
@@ -14559,7 +15035,7 @@
                   </a:tcPr>
                 </a:tc>
               </a:tr>
-              <a:tr h="228600">
+              <a:tr h="201168">
                 <a:tc>
                   <a:txBody>
                     <a:bodyPr/>
@@ -14572,6 +15048,186 @@
                             <a:srgbClr val="1E293B"/>
                           </a:solidFill>
                         </a:rPr>
+                        <a:t>vrtsim_pc5_csi_acquisition_psfch_*</a:t>
+                      </a:r>
+                    </a:p>
+                  </a:txBody>
+                  <a:tcPr anchor="ctr">
+                    <a:solidFill>
+                      <a:srgbClr val="FFFFFF"/>
+                    </a:solidFill>
+                  </a:tcPr>
+                </a:tc>
+                <a:tc>
+                  <a:txBody>
+                    <a:bodyPr/>
+                    <a:lstStyle/>
+                    <a:p>
+                      <a:pPr algn="ctr"/>
+                      <a:r>
+                        <a:rPr sz="1000" b="0">
+                          <a:solidFill>
+                            <a:srgbClr val="1E293B"/>
+                          </a:solidFill>
+                        </a:rPr>
+                        <a:t>SL Mode 2</a:t>
+                      </a:r>
+                    </a:p>
+                  </a:txBody>
+                  <a:tcPr anchor="ctr">
+                    <a:solidFill>
+                      <a:srgbClr val="FFFFFF"/>
+                    </a:solidFill>
+                  </a:tcPr>
+                </a:tc>
+                <a:tc>
+                  <a:txBody>
+                    <a:bodyPr/>
+                    <a:lstStyle/>
+                    <a:p>
+                      <a:pPr algn="ctr"/>
+                      <a:r>
+                        <a:rPr sz="1000" b="0">
+                          <a:solidFill>
+                            <a:srgbClr val="1E293B"/>
+                          </a:solidFill>
+                        </a:rPr>
+                        <a:t>1</a:t>
+                      </a:r>
+                    </a:p>
+                  </a:txBody>
+                  <a:tcPr anchor="ctr">
+                    <a:solidFill>
+                      <a:srgbClr val="FFFFFF"/>
+                    </a:solidFill>
+                  </a:tcPr>
+                </a:tc>
+                <a:tc>
+                  <a:txBody>
+                    <a:bodyPr/>
+                    <a:lstStyle/>
+                    <a:p>
+                      <a:pPr algn="l"/>
+                      <a:r>
+                        <a:rPr sz="1000" b="0">
+                          <a:solidFill>
+                            <a:srgbClr val="1E293B"/>
+                          </a:solidFill>
+                        </a:rPr>
+                        <a:t>PC5 CSI/PSFCH parametric sweep over shared-memory radio (8 combos)</a:t>
+                      </a:r>
+                    </a:p>
+                  </a:txBody>
+                  <a:tcPr anchor="ctr">
+                    <a:solidFill>
+                      <a:srgbClr val="FFFFFF"/>
+                    </a:solidFill>
+                  </a:tcPr>
+                </a:tc>
+              </a:tr>
+              <a:tr h="201168">
+                <a:tc>
+                  <a:txBody>
+                    <a:bodyPr/>
+                    <a:lstStyle/>
+                    <a:p>
+                      <a:pPr algn="l"/>
+                      <a:r>
+                        <a:rPr sz="1000" b="0">
+                          <a:solidFill>
+                            <a:srgbClr val="1E293B"/>
+                          </a:solidFill>
+                        </a:rPr>
+                        <a:t>vrtsim_pc5_iperf3_test_on_local_host</a:t>
+                      </a:r>
+                    </a:p>
+                  </a:txBody>
+                  <a:tcPr anchor="ctr">
+                    <a:solidFill>
+                      <a:srgbClr val="F4F8FC"/>
+                    </a:solidFill>
+                  </a:tcPr>
+                </a:tc>
+                <a:tc>
+                  <a:txBody>
+                    <a:bodyPr/>
+                    <a:lstStyle/>
+                    <a:p>
+                      <a:pPr algn="ctr"/>
+                      <a:r>
+                        <a:rPr sz="1000" b="0">
+                          <a:solidFill>
+                            <a:srgbClr val="1E293B"/>
+                          </a:solidFill>
+                        </a:rPr>
+                        <a:t>SL Mode 2</a:t>
+                      </a:r>
+                    </a:p>
+                  </a:txBody>
+                  <a:tcPr anchor="ctr">
+                    <a:solidFill>
+                      <a:srgbClr val="F4F8FC"/>
+                    </a:solidFill>
+                  </a:tcPr>
+                </a:tc>
+                <a:tc>
+                  <a:txBody>
+                    <a:bodyPr/>
+                    <a:lstStyle/>
+                    <a:p>
+                      <a:pPr algn="ctr"/>
+                      <a:r>
+                        <a:rPr sz="1000" b="0">
+                          <a:solidFill>
+                            <a:srgbClr val="1E293B"/>
+                          </a:solidFill>
+                        </a:rPr>
+                        <a:t>1</a:t>
+                      </a:r>
+                    </a:p>
+                  </a:txBody>
+                  <a:tcPr anchor="ctr">
+                    <a:solidFill>
+                      <a:srgbClr val="F4F8FC"/>
+                    </a:solidFill>
+                  </a:tcPr>
+                </a:tc>
+                <a:tc>
+                  <a:txBody>
+                    <a:bodyPr/>
+                    <a:lstStyle/>
+                    <a:p>
+                      <a:pPr algn="l"/>
+                      <a:r>
+                        <a:rPr sz="1000" b="0">
+                          <a:solidFill>
+                            <a:srgbClr val="1E293B"/>
+                          </a:solidFill>
+                        </a:rPr>
+                        <a:t>PC5 iperf3 bandwidth sweep over shared-memory radio</a:t>
+                      </a:r>
+                    </a:p>
+                  </a:txBody>
+                  <a:tcPr anchor="ctr">
+                    <a:solidFill>
+                      <a:srgbClr val="F4F8FC"/>
+                    </a:solidFill>
+                  </a:tcPr>
+                </a:tc>
+              </a:tr>
+              <a:tr h="201168">
+                <a:tc>
+                  <a:txBody>
+                    <a:bodyPr/>
+                    <a:lstStyle/>
+                    <a:p>
+                      <a:pPr algn="l"/>
+                      <a:r>
+                        <a:rPr sz="1000" b="0">
+                          <a:solidFill>
+                            <a:srgbClr val="1E293B"/>
+                          </a:solidFill>
+                        </a:rPr>
                         <a:t>vrtsim_slmode1_srap_ping_test_on_local_host</a:t>
                       </a:r>
                     </a:p>
@@ -14639,6 +15295,186 @@
                           </a:solidFill>
                         </a:rPr>
                         <a:t>U2N relay ping (SRAP) over shared-memory radio; launch-order/timing sensitive</a:t>
+                      </a:r>
+                    </a:p>
+                  </a:txBody>
+                  <a:tcPr anchor="ctr">
+                    <a:solidFill>
+                      <a:srgbClr val="FFFFFF"/>
+                    </a:solidFill>
+                  </a:tcPr>
+                </a:tc>
+              </a:tr>
+              <a:tr h="201168">
+                <a:tc>
+                  <a:txBody>
+                    <a:bodyPr/>
+                    <a:lstStyle/>
+                    <a:p>
+                      <a:pPr algn="l"/>
+                      <a:r>
+                        <a:rPr sz="1000" b="0">
+                          <a:solidFill>
+                            <a:srgbClr val="1E293B"/>
+                          </a:solidFill>
+                        </a:rPr>
+                        <a:t>vrtsim_slmode1_srap_csi_acquisition_psfch_*</a:t>
+                      </a:r>
+                    </a:p>
+                  </a:txBody>
+                  <a:tcPr anchor="ctr">
+                    <a:solidFill>
+                      <a:srgbClr val="F4F8FC"/>
+                    </a:solidFill>
+                  </a:tcPr>
+                </a:tc>
+                <a:tc>
+                  <a:txBody>
+                    <a:bodyPr/>
+                    <a:lstStyle/>
+                    <a:p>
+                      <a:pPr algn="ctr"/>
+                      <a:r>
+                        <a:rPr sz="1000" b="0">
+                          <a:solidFill>
+                            <a:srgbClr val="1E293B"/>
+                          </a:solidFill>
+                        </a:rPr>
+                        <a:t>SL Mode 1</a:t>
+                      </a:r>
+                    </a:p>
+                  </a:txBody>
+                  <a:tcPr anchor="ctr">
+                    <a:solidFill>
+                      <a:srgbClr val="F4F8FC"/>
+                    </a:solidFill>
+                  </a:tcPr>
+                </a:tc>
+                <a:tc>
+                  <a:txBody>
+                    <a:bodyPr/>
+                    <a:lstStyle/>
+                    <a:p>
+                      <a:pPr algn="ctr"/>
+                      <a:r>
+                        <a:rPr sz="1000" b="0">
+                          <a:solidFill>
+                            <a:srgbClr val="1E293B"/>
+                          </a:solidFill>
+                        </a:rPr>
+                        <a:t>1</a:t>
+                      </a:r>
+                    </a:p>
+                  </a:txBody>
+                  <a:tcPr anchor="ctr">
+                    <a:solidFill>
+                      <a:srgbClr val="F4F8FC"/>
+                    </a:solidFill>
+                  </a:tcPr>
+                </a:tc>
+                <a:tc>
+                  <a:txBody>
+                    <a:bodyPr/>
+                    <a:lstStyle/>
+                    <a:p>
+                      <a:pPr algn="l"/>
+                      <a:r>
+                        <a:rPr sz="1000" b="0">
+                          <a:solidFill>
+                            <a:srgbClr val="1E293B"/>
+                          </a:solidFill>
+                        </a:rPr>
+                        <a:t>U2N relay CSI/PSFCH parametric sweep over shared-memory radio (8 combos)</a:t>
+                      </a:r>
+                    </a:p>
+                  </a:txBody>
+                  <a:tcPr anchor="ctr">
+                    <a:solidFill>
+                      <a:srgbClr val="F4F8FC"/>
+                    </a:solidFill>
+                  </a:tcPr>
+                </a:tc>
+              </a:tr>
+              <a:tr h="201168">
+                <a:tc>
+                  <a:txBody>
+                    <a:bodyPr/>
+                    <a:lstStyle/>
+                    <a:p>
+                      <a:pPr algn="l"/>
+                      <a:r>
+                        <a:rPr sz="1000" b="0">
+                          <a:solidFill>
+                            <a:srgbClr val="1E293B"/>
+                          </a:solidFill>
+                        </a:rPr>
+                        <a:t>vrtsim_slmode1_srap_iperf3_test_on_local_host</a:t>
+                      </a:r>
+                    </a:p>
+                  </a:txBody>
+                  <a:tcPr anchor="ctr">
+                    <a:solidFill>
+                      <a:srgbClr val="FFFFFF"/>
+                    </a:solidFill>
+                  </a:tcPr>
+                </a:tc>
+                <a:tc>
+                  <a:txBody>
+                    <a:bodyPr/>
+                    <a:lstStyle/>
+                    <a:p>
+                      <a:pPr algn="ctr"/>
+                      <a:r>
+                        <a:rPr sz="1000" b="0">
+                          <a:solidFill>
+                            <a:srgbClr val="1E293B"/>
+                          </a:solidFill>
+                        </a:rPr>
+                        <a:t>SL Mode 1</a:t>
+                      </a:r>
+                    </a:p>
+                  </a:txBody>
+                  <a:tcPr anchor="ctr">
+                    <a:solidFill>
+                      <a:srgbClr val="FFFFFF"/>
+                    </a:solidFill>
+                  </a:tcPr>
+                </a:tc>
+                <a:tc>
+                  <a:txBody>
+                    <a:bodyPr/>
+                    <a:lstStyle/>
+                    <a:p>
+                      <a:pPr algn="ctr"/>
+                      <a:r>
+                        <a:rPr sz="1000" b="0">
+                          <a:solidFill>
+                            <a:srgbClr val="1E293B"/>
+                          </a:solidFill>
+                        </a:rPr>
+                        <a:t>1</a:t>
+                      </a:r>
+                    </a:p>
+                  </a:txBody>
+                  <a:tcPr anchor="ctr">
+                    <a:solidFill>
+                      <a:srgbClr val="FFFFFF"/>
+                    </a:solidFill>
+                  </a:tcPr>
+                </a:tc>
+                <a:tc>
+                  <a:txBody>
+                    <a:bodyPr/>
+                    <a:lstStyle/>
+                    <a:p>
+                      <a:pPr algn="l"/>
+                      <a:r>
+                        <a:rPr sz="1000" b="0">
+                          <a:solidFill>
+                            <a:srgbClr val="1E293B"/>
+                          </a:solidFill>
+                        </a:rPr>
+                        <a:t>U2N relay iperf3 sweep over shared-memory radio; client binds oaitun_ue2</a:t>
                       </a:r>
                     </a:p>
                   </a:txBody>

</xml_diff>